<commit_message>
site: feature Writer, Slides, and Sheets across the landing deck
</commit_message>
<xml_diff>
--- a/slides/landing-tall.pptx
+++ b/slides/landing-tall.pptx
@@ -12,6 +12,8 @@
     <p:sldId id="257" r:id="rIdS2"/>
     <p:sldId id="258" r:id="rIdS3"/>
     <p:sldId id="259" r:id="rIdS4"/>
+    <p:sldId id="260" r:id="rIdS5"/>
+    <p:sldId id="261" r:id="rIdS6"/>
   </p:sldIdLst>
   <p:sldSz cx="5715000" cy="9144000"/>
   <p:notesSz cx="6858000" cy="9144000"/>
@@ -2400,7 +2402,7 @@
                 <a:latin typeface="Calibri"/>
                 <a:cs typeface="Calibri"/>
               </a:rPr>
-              <a:t>An open source office suite.</a:t>
+              <a:t>Writer. Slides. Sheets.</a:t>
             </a:r>
             <a:endParaRPr lang="en-US" sz="2300" b="0" i="0" u="none" strike="noStrike" dirty="0">
               <a:solidFill>
@@ -2431,7 +2433,7 @@
                 <a:latin typeface="Calibri"/>
                 <a:cs typeface="Calibri"/>
               </a:rPr>
-              <a:t>Starting with Writer.</a:t>
+              <a:t>An open source office suite.</a:t>
             </a:r>
             <a:endParaRPr lang="en-US" sz="2300" b="0" i="0" u="none" strike="noStrike" dirty="0">
               <a:solidFill>
@@ -2445,63 +2447,14 @@
       </p:sp>
       <p:sp>
         <p:nvSpPr>
-          <p:cNvPr id="5" name="Rectangle 8"/>
+          <p:cNvPr id="5" name="Rounded Rectangle 8"/>
           <p:cNvSpPr/>
           <p:nvPr/>
         </p:nvSpPr>
         <p:spPr>
-          <a:xfrm rot="-600000">
-            <a:off x="2616200" y="5969000"/>
-            <a:ext cx="2184400" cy="2641600"/>
-          </a:xfrm>
-          <a:prstGeom prst="rect">
-            <a:avLst/>
-          </a:prstGeom>
-          <a:solidFill>
-            <a:srgbClr val="92ADFF"/>
-          </a:solidFill>
-          <a:ln>
-            <a:noFill/>
-          </a:ln>
-        </p:spPr>
-        <p:txBody>
-          <a:bodyPr wrap="square" lIns="91440" tIns="45720" rIns="91440" bIns="45720" anchor="ctr" rtlCol="0">
-            <a:noAutofit/>
-          </a:bodyPr>
-          <a:lstStyle/>
-          <a:p>
-            <a:pPr algn="ctr" marL="0" indent="0">
-              <a:lnSpc>
-                <a:spcPct val="100000"/>
-              </a:lnSpc>
-              <a:spcBef>
-                <a:spcPts val="0"/>
-              </a:spcBef>
-              <a:spcAft>
-                <a:spcPts val="0"/>
-              </a:spcAft>
-              <a:buNone/>
-            </a:pPr>
-            <a:endParaRPr lang="en-US" sz="1800" b="0" i="0" u="none" strike="noStrike" dirty="0">
-              <a:solidFill>
-                <a:srgbClr val="FFFFFF"/>
-              </a:solidFill>
-              <a:latin typeface="Calibri"/>
-              <a:cs typeface="Calibri"/>
-            </a:endParaRPr>
-          </a:p>
-        </p:txBody>
-      </p:sp>
-      <p:sp>
-        <p:nvSpPr>
-          <p:cNvPr id="6" name="Rounded Rectangle 9"/>
-          <p:cNvSpPr/>
-          <p:nvPr/>
-        </p:nvSpPr>
-        <p:spPr>
-          <a:xfrm>
-            <a:off x="2971800" y="5892800"/>
-            <a:ext cx="2184400" cy="2641600"/>
+          <a:xfrm>
+            <a:off x="406400" y="6096000"/>
+            <a:ext cx="1549400" cy="1981200"/>
           </a:xfrm>
           <a:prstGeom prst="roundRect">
             <a:avLst/>
@@ -2543,14 +2496,63 @@
       </p:sp>
       <p:sp>
         <p:nvSpPr>
+          <p:cNvPr id="6" name="Rounded Rectangle 9"/>
+          <p:cNvSpPr/>
+          <p:nvPr/>
+        </p:nvSpPr>
+        <p:spPr>
+          <a:xfrm>
+            <a:off x="584200" y="6273800"/>
+            <a:ext cx="533400" cy="533400"/>
+          </a:xfrm>
+          <a:prstGeom prst="roundRect">
+            <a:avLst/>
+          </a:prstGeom>
+          <a:solidFill>
+            <a:srgbClr val="2449DF"/>
+          </a:solidFill>
+          <a:ln>
+            <a:noFill/>
+          </a:ln>
+        </p:spPr>
+        <p:txBody>
+          <a:bodyPr wrap="square" lIns="91440" tIns="45720" rIns="91440" bIns="45720" anchor="ctr" rtlCol="0">
+            <a:noAutofit/>
+          </a:bodyPr>
+          <a:lstStyle/>
+          <a:p>
+            <a:pPr algn="ctr" marL="0" indent="0">
+              <a:lnSpc>
+                <a:spcPct val="100000"/>
+              </a:lnSpc>
+              <a:spcBef>
+                <a:spcPts val="0"/>
+              </a:spcBef>
+              <a:spcAft>
+                <a:spcPts val="0"/>
+              </a:spcAft>
+              <a:buNone/>
+            </a:pPr>
+            <a:endParaRPr lang="en-US" sz="1800" b="0" i="0" u="none" strike="noStrike" dirty="0">
+              <a:solidFill>
+                <a:srgbClr val="FFFFFF"/>
+              </a:solidFill>
+              <a:latin typeface="Calibri"/>
+              <a:cs typeface="Calibri"/>
+            </a:endParaRPr>
+          </a:p>
+        </p:txBody>
+      </p:sp>
+      <p:sp>
+        <p:nvSpPr>
           <p:cNvPr id="7" name="TextBox 10"/>
           <p:cNvSpPr txBox="1"/>
           <p:nvPr/>
         </p:nvSpPr>
         <p:spPr>
           <a:xfrm>
-            <a:off x="3251200" y="6096000"/>
-            <a:ext cx="1803400" cy="3048000"/>
+            <a:off x="698500" y="6299200"/>
+            <a:ext cx="711200" cy="2844800"/>
           </a:xfrm>
           <a:prstGeom prst="rect">
             <a:avLst/>
@@ -2579,65 +2581,16 @@
               <a:buNone/>
             </a:pPr>
             <a:r>
-              <a:rPr lang="en-US" sz="4800" b="1" i="0" u="none" strike="noStrike" dirty="0">
-                <a:solidFill>
-                  <a:srgbClr val="2449DF"/>
+              <a:rPr lang="en-US" sz="2900" b="1" i="0" u="none" strike="noStrike" dirty="0">
+                <a:solidFill>
+                  <a:srgbClr val="FFFFFF"/>
                 </a:solidFill>
                 <a:latin typeface="Calibri"/>
                 <a:cs typeface="Calibri"/>
               </a:rPr>
               <a:t>W</a:t>
             </a:r>
-            <a:endParaRPr lang="en-US" sz="4800" b="1" i="0" u="none" strike="noStrike" dirty="0">
-              <a:solidFill>
-                <a:srgbClr val="2449DF"/>
-              </a:solidFill>
-              <a:latin typeface="Calibri"/>
-              <a:cs typeface="Calibri"/>
-            </a:endParaRPr>
-          </a:p>
-        </p:txBody>
-      </p:sp>
-      <p:sp>
-        <p:nvSpPr>
-          <p:cNvPr id="8" name="Rectangle 11"/>
-          <p:cNvSpPr/>
-          <p:nvPr/>
-        </p:nvSpPr>
-        <p:spPr>
-          <a:xfrm>
-            <a:off x="3276600" y="7200900"/>
-            <a:ext cx="1574800" cy="50800"/>
-          </a:xfrm>
-          <a:prstGeom prst="rect">
-            <a:avLst/>
-          </a:prstGeom>
-          <a:solidFill>
-            <a:srgbClr val="DDE5F5"/>
-          </a:solidFill>
-          <a:ln>
-            <a:noFill/>
-          </a:ln>
-        </p:spPr>
-        <p:txBody>
-          <a:bodyPr wrap="square" lIns="91440" tIns="45720" rIns="91440" bIns="45720" anchor="ctr" rtlCol="0">
-            <a:noAutofit/>
-          </a:bodyPr>
-          <a:lstStyle/>
-          <a:p>
-            <a:pPr algn="ctr" marL="0" indent="0">
-              <a:lnSpc>
-                <a:spcPct val="100000"/>
-              </a:lnSpc>
-              <a:spcBef>
-                <a:spcPts val="0"/>
-              </a:spcBef>
-              <a:spcAft>
-                <a:spcPts val="0"/>
-              </a:spcAft>
-              <a:buNone/>
-            </a:pPr>
-            <a:endParaRPr lang="en-US" sz="1800" b="0" i="0" u="none" strike="noStrike" dirty="0">
+            <a:endParaRPr lang="en-US" sz="2900" b="1" i="0" u="none" strike="noStrike" dirty="0">
               <a:solidFill>
                 <a:srgbClr val="FFFFFF"/>
               </a:solidFill>
@@ -2649,210 +2602,14 @@
       </p:sp>
       <p:sp>
         <p:nvSpPr>
-          <p:cNvPr id="9" name="Rectangle 12"/>
-          <p:cNvSpPr/>
-          <p:nvPr/>
-        </p:nvSpPr>
-        <p:spPr>
-          <a:xfrm>
-            <a:off x="3276600" y="7391400"/>
-            <a:ext cx="1574800" cy="50800"/>
-          </a:xfrm>
-          <a:prstGeom prst="rect">
-            <a:avLst/>
-          </a:prstGeom>
-          <a:solidFill>
-            <a:srgbClr val="DDE5F5"/>
-          </a:solidFill>
-          <a:ln>
-            <a:noFill/>
-          </a:ln>
-        </p:spPr>
-        <p:txBody>
-          <a:bodyPr wrap="square" lIns="91440" tIns="45720" rIns="91440" bIns="45720" anchor="ctr" rtlCol="0">
-            <a:noAutofit/>
-          </a:bodyPr>
-          <a:lstStyle/>
-          <a:p>
-            <a:pPr algn="ctr" marL="0" indent="0">
-              <a:lnSpc>
-                <a:spcPct val="100000"/>
-              </a:lnSpc>
-              <a:spcBef>
-                <a:spcPts val="0"/>
-              </a:spcBef>
-              <a:spcAft>
-                <a:spcPts val="0"/>
-              </a:spcAft>
-              <a:buNone/>
-            </a:pPr>
-            <a:endParaRPr lang="en-US" sz="1800" b="0" i="0" u="none" strike="noStrike" dirty="0">
-              <a:solidFill>
-                <a:srgbClr val="FFFFFF"/>
-              </a:solidFill>
-              <a:latin typeface="Calibri"/>
-              <a:cs typeface="Calibri"/>
-            </a:endParaRPr>
-          </a:p>
-        </p:txBody>
-      </p:sp>
-      <p:sp>
-        <p:nvSpPr>
-          <p:cNvPr id="10" name="Rectangle 13"/>
-          <p:cNvSpPr/>
-          <p:nvPr/>
-        </p:nvSpPr>
-        <p:spPr>
-          <a:xfrm>
-            <a:off x="3276600" y="7581900"/>
-            <a:ext cx="1574800" cy="50800"/>
-          </a:xfrm>
-          <a:prstGeom prst="rect">
-            <a:avLst/>
-          </a:prstGeom>
-          <a:solidFill>
-            <a:srgbClr val="DDE5F5"/>
-          </a:solidFill>
-          <a:ln>
-            <a:noFill/>
-          </a:ln>
-        </p:spPr>
-        <p:txBody>
-          <a:bodyPr wrap="square" lIns="91440" tIns="45720" rIns="91440" bIns="45720" anchor="ctr" rtlCol="0">
-            <a:noAutofit/>
-          </a:bodyPr>
-          <a:lstStyle/>
-          <a:p>
-            <a:pPr algn="ctr" marL="0" indent="0">
-              <a:lnSpc>
-                <a:spcPct val="100000"/>
-              </a:lnSpc>
-              <a:spcBef>
-                <a:spcPts val="0"/>
-              </a:spcBef>
-              <a:spcAft>
-                <a:spcPts val="0"/>
-              </a:spcAft>
-              <a:buNone/>
-            </a:pPr>
-            <a:endParaRPr lang="en-US" sz="1800" b="0" i="0" u="none" strike="noStrike" dirty="0">
-              <a:solidFill>
-                <a:srgbClr val="FFFFFF"/>
-              </a:solidFill>
-              <a:latin typeface="Calibri"/>
-              <a:cs typeface="Calibri"/>
-            </a:endParaRPr>
-          </a:p>
-        </p:txBody>
-      </p:sp>
-      <p:sp>
-        <p:nvSpPr>
-          <p:cNvPr id="11" name="Rectangle 14"/>
-          <p:cNvSpPr/>
-          <p:nvPr/>
-        </p:nvSpPr>
-        <p:spPr>
-          <a:xfrm>
-            <a:off x="3276600" y="7772400"/>
-            <a:ext cx="1574800" cy="50800"/>
-          </a:xfrm>
-          <a:prstGeom prst="rect">
-            <a:avLst/>
-          </a:prstGeom>
-          <a:solidFill>
-            <a:srgbClr val="DDE5F5"/>
-          </a:solidFill>
-          <a:ln>
-            <a:noFill/>
-          </a:ln>
-        </p:spPr>
-        <p:txBody>
-          <a:bodyPr wrap="square" lIns="91440" tIns="45720" rIns="91440" bIns="45720" anchor="ctr" rtlCol="0">
-            <a:noAutofit/>
-          </a:bodyPr>
-          <a:lstStyle/>
-          <a:p>
-            <a:pPr algn="ctr" marL="0" indent="0">
-              <a:lnSpc>
-                <a:spcPct val="100000"/>
-              </a:lnSpc>
-              <a:spcBef>
-                <a:spcPts val="0"/>
-              </a:spcBef>
-              <a:spcAft>
-                <a:spcPts val="0"/>
-              </a:spcAft>
-              <a:buNone/>
-            </a:pPr>
-            <a:endParaRPr lang="en-US" sz="1800" b="0" i="0" u="none" strike="noStrike" dirty="0">
-              <a:solidFill>
-                <a:srgbClr val="FFFFFF"/>
-              </a:solidFill>
-              <a:latin typeface="Calibri"/>
-              <a:cs typeface="Calibri"/>
-            </a:endParaRPr>
-          </a:p>
-        </p:txBody>
-      </p:sp>
-      <p:sp>
-        <p:nvSpPr>
-          <p:cNvPr id="12" name="Rectangle 15"/>
-          <p:cNvSpPr/>
-          <p:nvPr/>
-        </p:nvSpPr>
-        <p:spPr>
-          <a:xfrm>
-            <a:off x="3276600" y="7962900"/>
-            <a:ext cx="1104900" cy="50800"/>
-          </a:xfrm>
-          <a:prstGeom prst="rect">
-            <a:avLst/>
-          </a:prstGeom>
-          <a:solidFill>
-            <a:srgbClr val="DDE5F5"/>
-          </a:solidFill>
-          <a:ln>
-            <a:noFill/>
-          </a:ln>
-        </p:spPr>
-        <p:txBody>
-          <a:bodyPr wrap="square" lIns="91440" tIns="45720" rIns="91440" bIns="45720" anchor="ctr" rtlCol="0">
-            <a:noAutofit/>
-          </a:bodyPr>
-          <a:lstStyle/>
-          <a:p>
-            <a:pPr algn="ctr" marL="0" indent="0">
-              <a:lnSpc>
-                <a:spcPct val="100000"/>
-              </a:lnSpc>
-              <a:spcBef>
-                <a:spcPts val="0"/>
-              </a:spcBef>
-              <a:spcAft>
-                <a:spcPts val="0"/>
-              </a:spcAft>
-              <a:buNone/>
-            </a:pPr>
-            <a:endParaRPr lang="en-US" sz="1800" b="0" i="0" u="none" strike="noStrike" dirty="0">
-              <a:solidFill>
-                <a:srgbClr val="FFFFFF"/>
-              </a:solidFill>
-              <a:latin typeface="Calibri"/>
-              <a:cs typeface="Calibri"/>
-            </a:endParaRPr>
-          </a:p>
-        </p:txBody>
-      </p:sp>
-      <p:sp>
-        <p:nvSpPr>
-          <p:cNvPr id="13" name="TextBox 16"/>
+          <p:cNvPr id="8" name="TextBox 11"/>
           <p:cNvSpPr txBox="1"/>
           <p:nvPr/>
         </p:nvSpPr>
         <p:spPr>
           <a:xfrm>
-            <a:off x="406400" y="7048500"/>
-            <a:ext cx="2286000" cy="2095500"/>
+            <a:off x="584200" y="7023100"/>
+            <a:ext cx="1270000" cy="2120900"/>
           </a:xfrm>
           <a:prstGeom prst="rect">
             <a:avLst/>
@@ -2881,35 +2638,35 @@
               <a:buNone/>
             </a:pPr>
             <a:r>
-              <a:rPr lang="en-US" sz="1400" b="1" i="0" u="none" strike="noStrike" dirty="0">
-                <a:solidFill>
-                  <a:srgbClr val="FFFFFF"/>
+              <a:rPr lang="en-US" sz="2400" b="1" i="0" u="none" strike="noStrike" dirty="0">
+                <a:solidFill>
+                  <a:srgbClr val="132442"/>
                 </a:solidFill>
                 <a:latin typeface="Calibri"/>
                 <a:cs typeface="Calibri"/>
               </a:rPr>
-              <a:t>WRITER IS LIVE</a:t>
-            </a:r>
-            <a:endParaRPr lang="en-US" sz="1400" b="1" i="0" u="none" strike="noStrike" dirty="0">
-              <a:solidFill>
-                <a:srgbClr val="FFFFFF"/>
-              </a:solidFill>
-              <a:latin typeface="Calibri"/>
-              <a:cs typeface="Calibri"/>
-            </a:endParaRPr>
-          </a:p>
-        </p:txBody>
-      </p:sp>
-      <p:sp>
-        <p:nvSpPr>
-          <p:cNvPr id="14" name="TextBox 17"/>
+              <a:t>Writer</a:t>
+            </a:r>
+            <a:endParaRPr lang="en-US" sz="2400" b="1" i="0" u="none" strike="noStrike" dirty="0">
+              <a:solidFill>
+                <a:srgbClr val="132442"/>
+              </a:solidFill>
+              <a:latin typeface="Calibri"/>
+              <a:cs typeface="Calibri"/>
+            </a:endParaRPr>
+          </a:p>
+        </p:txBody>
+      </p:sp>
+      <p:sp>
+        <p:nvSpPr>
+          <p:cNvPr id="9" name="TextBox 12"/>
           <p:cNvSpPr txBox="1"/>
           <p:nvPr/>
         </p:nvSpPr>
         <p:spPr>
           <a:xfrm>
-            <a:off x="406400" y="7480300"/>
-            <a:ext cx="2286000" cy="1663700"/>
+            <a:off x="584200" y="7556500"/>
+            <a:ext cx="1270000" cy="1587500"/>
           </a:xfrm>
           <a:prstGeom prst="rect">
             <a:avLst/>
@@ -2938,15 +2695,64 @@
               <a:buNone/>
             </a:pPr>
             <a:r>
-              <a:rPr lang="en-US" sz="1800" b="0" i="0" u="none" strike="noStrike" dirty="0">
-                <a:solidFill>
-                  <a:srgbClr val="FFFFFF"/>
+              <a:rPr lang="en-US" sz="1300" b="0" i="0" u="none" strike="noStrike" dirty="0">
+                <a:solidFill>
+                  <a:srgbClr val="536782"/>
                 </a:solidFill>
                 <a:latin typeface="Calibri"/>
                 <a:cs typeface="Calibri"/>
               </a:rPr>
-              <a:t>A fresh page.</a:t>
-            </a:r>
+              <a:t>Documents</a:t>
+            </a:r>
+            <a:endParaRPr lang="en-US" sz="1300" b="0" i="0" u="none" strike="noStrike" dirty="0">
+              <a:solidFill>
+                <a:srgbClr val="536782"/>
+              </a:solidFill>
+              <a:latin typeface="Calibri"/>
+              <a:cs typeface="Calibri"/>
+            </a:endParaRPr>
+          </a:p>
+        </p:txBody>
+      </p:sp>
+      <p:sp>
+        <p:nvSpPr>
+          <p:cNvPr id="10" name="Rounded Rectangle 13"/>
+          <p:cNvSpPr/>
+          <p:nvPr/>
+        </p:nvSpPr>
+        <p:spPr>
+          <a:xfrm>
+            <a:off x="2082800" y="6096000"/>
+            <a:ext cx="1549400" cy="1981200"/>
+          </a:xfrm>
+          <a:prstGeom prst="roundRect">
+            <a:avLst/>
+          </a:prstGeom>
+          <a:solidFill>
+            <a:srgbClr val="FFFFFF"/>
+          </a:solidFill>
+          <a:ln>
+            <a:noFill/>
+          </a:ln>
+        </p:spPr>
+        <p:txBody>
+          <a:bodyPr wrap="square" lIns="91440" tIns="45720" rIns="91440" bIns="45720" anchor="ctr" rtlCol="0">
+            <a:noAutofit/>
+          </a:bodyPr>
+          <a:lstStyle/>
+          <a:p>
+            <a:pPr algn="ctr" marL="0" indent="0">
+              <a:lnSpc>
+                <a:spcPct val="100000"/>
+              </a:lnSpc>
+              <a:spcBef>
+                <a:spcPts val="0"/>
+              </a:spcBef>
+              <a:spcAft>
+                <a:spcPts val="0"/>
+              </a:spcAft>
+              <a:buNone/>
+            </a:pPr>
             <a:endParaRPr lang="en-US" sz="1800" b="0" i="0" u="none" strike="noStrike" dirty="0">
               <a:solidFill>
                 <a:srgbClr val="FFFFFF"/>
@@ -2955,6 +2761,81 @@
               <a:cs typeface="Calibri"/>
             </a:endParaRPr>
           </a:p>
+        </p:txBody>
+      </p:sp>
+      <p:sp>
+        <p:nvSpPr>
+          <p:cNvPr id="11" name="Rounded Rectangle 14"/>
+          <p:cNvSpPr/>
+          <p:nvPr/>
+        </p:nvSpPr>
+        <p:spPr>
+          <a:xfrm>
+            <a:off x="2260600" y="6273800"/>
+            <a:ext cx="533400" cy="533400"/>
+          </a:xfrm>
+          <a:prstGeom prst="roundRect">
+            <a:avLst/>
+          </a:prstGeom>
+          <a:solidFill>
+            <a:srgbClr val="E45B35"/>
+          </a:solidFill>
+          <a:ln>
+            <a:noFill/>
+          </a:ln>
+        </p:spPr>
+        <p:txBody>
+          <a:bodyPr wrap="square" lIns="91440" tIns="45720" rIns="91440" bIns="45720" anchor="ctr" rtlCol="0">
+            <a:noAutofit/>
+          </a:bodyPr>
+          <a:lstStyle/>
+          <a:p>
+            <a:pPr algn="ctr" marL="0" indent="0">
+              <a:lnSpc>
+                <a:spcPct val="100000"/>
+              </a:lnSpc>
+              <a:spcBef>
+                <a:spcPts val="0"/>
+              </a:spcBef>
+              <a:spcAft>
+                <a:spcPts val="0"/>
+              </a:spcAft>
+              <a:buNone/>
+            </a:pPr>
+            <a:endParaRPr lang="en-US" sz="1800" b="0" i="0" u="none" strike="noStrike" dirty="0">
+              <a:solidFill>
+                <a:srgbClr val="FFFFFF"/>
+              </a:solidFill>
+              <a:latin typeface="Calibri"/>
+              <a:cs typeface="Calibri"/>
+            </a:endParaRPr>
+          </a:p>
+        </p:txBody>
+      </p:sp>
+      <p:sp>
+        <p:nvSpPr>
+          <p:cNvPr id="12" name="TextBox 15"/>
+          <p:cNvSpPr txBox="1"/>
+          <p:nvPr/>
+        </p:nvSpPr>
+        <p:spPr>
+          <a:xfrm>
+            <a:off x="2374900" y="6299200"/>
+            <a:ext cx="711200" cy="2844800"/>
+          </a:xfrm>
+          <a:prstGeom prst="rect">
+            <a:avLst/>
+          </a:prstGeom>
+          <a:noFill/>
+          <a:ln>
+            <a:noFill/>
+          </a:ln>
+        </p:spPr>
+        <p:txBody>
+          <a:bodyPr wrap="square" lIns="0" tIns="0" rIns="0" bIns="0" anchor="t" rtlCol="0">
+            <a:spAutoFit/>
+          </a:bodyPr>
+          <a:lstStyle/>
           <a:p>
             <a:pPr algn="l" marL="0" indent="0">
               <a:lnSpc>
@@ -2969,16 +2850,456 @@
               <a:buNone/>
             </a:pPr>
             <a:r>
-              <a:rPr lang="en-US" sz="1800" b="0" i="0" u="none" strike="noStrike" dirty="0">
+              <a:rPr lang="en-US" sz="2900" b="1" i="0" u="none" strike="noStrike" dirty="0">
                 <a:solidFill>
                   <a:srgbClr val="FFFFFF"/>
                 </a:solidFill>
                 <a:latin typeface="Calibri"/>
                 <a:cs typeface="Calibri"/>
               </a:rPr>
-              <a:t>A familiar feel.</a:t>
-            </a:r>
+              <a:t>S</a:t>
+            </a:r>
+            <a:endParaRPr lang="en-US" sz="2900" b="1" i="0" u="none" strike="noStrike" dirty="0">
+              <a:solidFill>
+                <a:srgbClr val="FFFFFF"/>
+              </a:solidFill>
+              <a:latin typeface="Calibri"/>
+              <a:cs typeface="Calibri"/>
+            </a:endParaRPr>
+          </a:p>
+        </p:txBody>
+      </p:sp>
+      <p:sp>
+        <p:nvSpPr>
+          <p:cNvPr id="13" name="TextBox 16"/>
+          <p:cNvSpPr txBox="1"/>
+          <p:nvPr/>
+        </p:nvSpPr>
+        <p:spPr>
+          <a:xfrm>
+            <a:off x="2260600" y="7023100"/>
+            <a:ext cx="1270000" cy="2120900"/>
+          </a:xfrm>
+          <a:prstGeom prst="rect">
+            <a:avLst/>
+          </a:prstGeom>
+          <a:noFill/>
+          <a:ln>
+            <a:noFill/>
+          </a:ln>
+        </p:spPr>
+        <p:txBody>
+          <a:bodyPr wrap="square" lIns="0" tIns="0" rIns="0" bIns="0" anchor="t" rtlCol="0">
+            <a:spAutoFit/>
+          </a:bodyPr>
+          <a:lstStyle/>
+          <a:p>
+            <a:pPr algn="l" marL="0" indent="0">
+              <a:lnSpc>
+                <a:spcPct val="100000"/>
+              </a:lnSpc>
+              <a:spcBef>
+                <a:spcPts val="0"/>
+              </a:spcBef>
+              <a:spcAft>
+                <a:spcPts val="0"/>
+              </a:spcAft>
+              <a:buNone/>
+            </a:pPr>
+            <a:r>
+              <a:rPr lang="en-US" sz="2400" b="1" i="0" u="none" strike="noStrike" dirty="0">
+                <a:solidFill>
+                  <a:srgbClr val="132442"/>
+                </a:solidFill>
+                <a:latin typeface="Calibri"/>
+                <a:cs typeface="Calibri"/>
+              </a:rPr>
+              <a:t>Slides</a:t>
+            </a:r>
+            <a:endParaRPr lang="en-US" sz="2400" b="1" i="0" u="none" strike="noStrike" dirty="0">
+              <a:solidFill>
+                <a:srgbClr val="132442"/>
+              </a:solidFill>
+              <a:latin typeface="Calibri"/>
+              <a:cs typeface="Calibri"/>
+            </a:endParaRPr>
+          </a:p>
+        </p:txBody>
+      </p:sp>
+      <p:sp>
+        <p:nvSpPr>
+          <p:cNvPr id="14" name="TextBox 17"/>
+          <p:cNvSpPr txBox="1"/>
+          <p:nvPr/>
+        </p:nvSpPr>
+        <p:spPr>
+          <a:xfrm>
+            <a:off x="2260600" y="7556500"/>
+            <a:ext cx="1270000" cy="1587500"/>
+          </a:xfrm>
+          <a:prstGeom prst="rect">
+            <a:avLst/>
+          </a:prstGeom>
+          <a:noFill/>
+          <a:ln>
+            <a:noFill/>
+          </a:ln>
+        </p:spPr>
+        <p:txBody>
+          <a:bodyPr wrap="square" lIns="0" tIns="0" rIns="0" bIns="0" anchor="t" rtlCol="0">
+            <a:spAutoFit/>
+          </a:bodyPr>
+          <a:lstStyle/>
+          <a:p>
+            <a:pPr algn="l" marL="0" indent="0">
+              <a:lnSpc>
+                <a:spcPct val="100000"/>
+              </a:lnSpc>
+              <a:spcBef>
+                <a:spcPts val="0"/>
+              </a:spcBef>
+              <a:spcAft>
+                <a:spcPts val="0"/>
+              </a:spcAft>
+              <a:buNone/>
+            </a:pPr>
+            <a:r>
+              <a:rPr lang="en-US" sz="1300" b="0" i="0" u="none" strike="noStrike" dirty="0">
+                <a:solidFill>
+                  <a:srgbClr val="536782"/>
+                </a:solidFill>
+                <a:latin typeface="Calibri"/>
+                <a:cs typeface="Calibri"/>
+              </a:rPr>
+              <a:t>Presentations</a:t>
+            </a:r>
+            <a:endParaRPr lang="en-US" sz="1300" b="0" i="0" u="none" strike="noStrike" dirty="0">
+              <a:solidFill>
+                <a:srgbClr val="536782"/>
+              </a:solidFill>
+              <a:latin typeface="Calibri"/>
+              <a:cs typeface="Calibri"/>
+            </a:endParaRPr>
+          </a:p>
+        </p:txBody>
+      </p:sp>
+      <p:sp>
+        <p:nvSpPr>
+          <p:cNvPr id="15" name="Rounded Rectangle 18"/>
+          <p:cNvSpPr/>
+          <p:nvPr/>
+        </p:nvSpPr>
+        <p:spPr>
+          <a:xfrm>
+            <a:off x="3759200" y="6096000"/>
+            <a:ext cx="1549400" cy="1981200"/>
+          </a:xfrm>
+          <a:prstGeom prst="roundRect">
+            <a:avLst/>
+          </a:prstGeom>
+          <a:solidFill>
+            <a:srgbClr val="FFFFFF"/>
+          </a:solidFill>
+          <a:ln>
+            <a:noFill/>
+          </a:ln>
+        </p:spPr>
+        <p:txBody>
+          <a:bodyPr wrap="square" lIns="91440" tIns="45720" rIns="91440" bIns="45720" anchor="ctr" rtlCol="0">
+            <a:noAutofit/>
+          </a:bodyPr>
+          <a:lstStyle/>
+          <a:p>
+            <a:pPr algn="ctr" marL="0" indent="0">
+              <a:lnSpc>
+                <a:spcPct val="100000"/>
+              </a:lnSpc>
+              <a:spcBef>
+                <a:spcPts val="0"/>
+              </a:spcBef>
+              <a:spcAft>
+                <a:spcPts val="0"/>
+              </a:spcAft>
+              <a:buNone/>
+            </a:pPr>
             <a:endParaRPr lang="en-US" sz="1800" b="0" i="0" u="none" strike="noStrike" dirty="0">
+              <a:solidFill>
+                <a:srgbClr val="FFFFFF"/>
+              </a:solidFill>
+              <a:latin typeface="Calibri"/>
+              <a:cs typeface="Calibri"/>
+            </a:endParaRPr>
+          </a:p>
+        </p:txBody>
+      </p:sp>
+      <p:sp>
+        <p:nvSpPr>
+          <p:cNvPr id="16" name="Rounded Rectangle 19"/>
+          <p:cNvSpPr/>
+          <p:nvPr/>
+        </p:nvSpPr>
+        <p:spPr>
+          <a:xfrm>
+            <a:off x="3937000" y="6273800"/>
+            <a:ext cx="533400" cy="533400"/>
+          </a:xfrm>
+          <a:prstGeom prst="roundRect">
+            <a:avLst/>
+          </a:prstGeom>
+          <a:solidFill>
+            <a:srgbClr val="13794D"/>
+          </a:solidFill>
+          <a:ln>
+            <a:noFill/>
+          </a:ln>
+        </p:spPr>
+        <p:txBody>
+          <a:bodyPr wrap="square" lIns="91440" tIns="45720" rIns="91440" bIns="45720" anchor="ctr" rtlCol="0">
+            <a:noAutofit/>
+          </a:bodyPr>
+          <a:lstStyle/>
+          <a:p>
+            <a:pPr algn="ctr" marL="0" indent="0">
+              <a:lnSpc>
+                <a:spcPct val="100000"/>
+              </a:lnSpc>
+              <a:spcBef>
+                <a:spcPts val="0"/>
+              </a:spcBef>
+              <a:spcAft>
+                <a:spcPts val="0"/>
+              </a:spcAft>
+              <a:buNone/>
+            </a:pPr>
+            <a:endParaRPr lang="en-US" sz="1800" b="0" i="0" u="none" strike="noStrike" dirty="0">
+              <a:solidFill>
+                <a:srgbClr val="FFFFFF"/>
+              </a:solidFill>
+              <a:latin typeface="Calibri"/>
+              <a:cs typeface="Calibri"/>
+            </a:endParaRPr>
+          </a:p>
+        </p:txBody>
+      </p:sp>
+      <p:sp>
+        <p:nvSpPr>
+          <p:cNvPr id="17" name="TextBox 20"/>
+          <p:cNvSpPr txBox="1"/>
+          <p:nvPr/>
+        </p:nvSpPr>
+        <p:spPr>
+          <a:xfrm>
+            <a:off x="4051300" y="6299200"/>
+            <a:ext cx="711200" cy="2844800"/>
+          </a:xfrm>
+          <a:prstGeom prst="rect">
+            <a:avLst/>
+          </a:prstGeom>
+          <a:noFill/>
+          <a:ln>
+            <a:noFill/>
+          </a:ln>
+        </p:spPr>
+        <p:txBody>
+          <a:bodyPr wrap="square" lIns="0" tIns="0" rIns="0" bIns="0" anchor="t" rtlCol="0">
+            <a:spAutoFit/>
+          </a:bodyPr>
+          <a:lstStyle/>
+          <a:p>
+            <a:pPr algn="l" marL="0" indent="0">
+              <a:lnSpc>
+                <a:spcPct val="100000"/>
+              </a:lnSpc>
+              <a:spcBef>
+                <a:spcPts val="0"/>
+              </a:spcBef>
+              <a:spcAft>
+                <a:spcPts val="0"/>
+              </a:spcAft>
+              <a:buNone/>
+            </a:pPr>
+            <a:r>
+              <a:rPr lang="en-US" sz="2900" b="1" i="0" u="none" strike="noStrike" dirty="0">
+                <a:solidFill>
+                  <a:srgbClr val="FFFFFF"/>
+                </a:solidFill>
+                <a:latin typeface="Calibri"/>
+                <a:cs typeface="Calibri"/>
+              </a:rPr>
+              <a:t>#</a:t>
+            </a:r>
+            <a:endParaRPr lang="en-US" sz="2900" b="1" i="0" u="none" strike="noStrike" dirty="0">
+              <a:solidFill>
+                <a:srgbClr val="FFFFFF"/>
+              </a:solidFill>
+              <a:latin typeface="Calibri"/>
+              <a:cs typeface="Calibri"/>
+            </a:endParaRPr>
+          </a:p>
+        </p:txBody>
+      </p:sp>
+      <p:sp>
+        <p:nvSpPr>
+          <p:cNvPr id="18" name="TextBox 21"/>
+          <p:cNvSpPr txBox="1"/>
+          <p:nvPr/>
+        </p:nvSpPr>
+        <p:spPr>
+          <a:xfrm>
+            <a:off x="3937000" y="7023100"/>
+            <a:ext cx="1270000" cy="2120900"/>
+          </a:xfrm>
+          <a:prstGeom prst="rect">
+            <a:avLst/>
+          </a:prstGeom>
+          <a:noFill/>
+          <a:ln>
+            <a:noFill/>
+          </a:ln>
+        </p:spPr>
+        <p:txBody>
+          <a:bodyPr wrap="square" lIns="0" tIns="0" rIns="0" bIns="0" anchor="t" rtlCol="0">
+            <a:spAutoFit/>
+          </a:bodyPr>
+          <a:lstStyle/>
+          <a:p>
+            <a:pPr algn="l" marL="0" indent="0">
+              <a:lnSpc>
+                <a:spcPct val="100000"/>
+              </a:lnSpc>
+              <a:spcBef>
+                <a:spcPts val="0"/>
+              </a:spcBef>
+              <a:spcAft>
+                <a:spcPts val="0"/>
+              </a:spcAft>
+              <a:buNone/>
+            </a:pPr>
+            <a:r>
+              <a:rPr lang="en-US" sz="2400" b="1" i="0" u="none" strike="noStrike" dirty="0">
+                <a:solidFill>
+                  <a:srgbClr val="132442"/>
+                </a:solidFill>
+                <a:latin typeface="Calibri"/>
+                <a:cs typeface="Calibri"/>
+              </a:rPr>
+              <a:t>Sheets</a:t>
+            </a:r>
+            <a:endParaRPr lang="en-US" sz="2400" b="1" i="0" u="none" strike="noStrike" dirty="0">
+              <a:solidFill>
+                <a:srgbClr val="132442"/>
+              </a:solidFill>
+              <a:latin typeface="Calibri"/>
+              <a:cs typeface="Calibri"/>
+            </a:endParaRPr>
+          </a:p>
+        </p:txBody>
+      </p:sp>
+      <p:sp>
+        <p:nvSpPr>
+          <p:cNvPr id="19" name="TextBox 22"/>
+          <p:cNvSpPr txBox="1"/>
+          <p:nvPr/>
+        </p:nvSpPr>
+        <p:spPr>
+          <a:xfrm>
+            <a:off x="3937000" y="7556500"/>
+            <a:ext cx="1270000" cy="1587500"/>
+          </a:xfrm>
+          <a:prstGeom prst="rect">
+            <a:avLst/>
+          </a:prstGeom>
+          <a:noFill/>
+          <a:ln>
+            <a:noFill/>
+          </a:ln>
+        </p:spPr>
+        <p:txBody>
+          <a:bodyPr wrap="square" lIns="0" tIns="0" rIns="0" bIns="0" anchor="t" rtlCol="0">
+            <a:spAutoFit/>
+          </a:bodyPr>
+          <a:lstStyle/>
+          <a:p>
+            <a:pPr algn="l" marL="0" indent="0">
+              <a:lnSpc>
+                <a:spcPct val="100000"/>
+              </a:lnSpc>
+              <a:spcBef>
+                <a:spcPts val="0"/>
+              </a:spcBef>
+              <a:spcAft>
+                <a:spcPts val="0"/>
+              </a:spcAft>
+              <a:buNone/>
+            </a:pPr>
+            <a:r>
+              <a:rPr lang="en-US" sz="1300" b="0" i="0" u="none" strike="noStrike" dirty="0">
+                <a:solidFill>
+                  <a:srgbClr val="536782"/>
+                </a:solidFill>
+                <a:latin typeface="Calibri"/>
+                <a:cs typeface="Calibri"/>
+              </a:rPr>
+              <a:t>Spreadsheets</a:t>
+            </a:r>
+            <a:endParaRPr lang="en-US" sz="1300" b="0" i="0" u="none" strike="noStrike" dirty="0">
+              <a:solidFill>
+                <a:srgbClr val="536782"/>
+              </a:solidFill>
+              <a:latin typeface="Calibri"/>
+              <a:cs typeface="Calibri"/>
+            </a:endParaRPr>
+          </a:p>
+        </p:txBody>
+      </p:sp>
+      <p:sp>
+        <p:nvSpPr>
+          <p:cNvPr id="20" name="TextBox 23"/>
+          <p:cNvSpPr txBox="1"/>
+          <p:nvPr/>
+        </p:nvSpPr>
+        <p:spPr>
+          <a:xfrm>
+            <a:off x="406400" y="8458200"/>
+            <a:ext cx="4902200" cy="685800"/>
+          </a:xfrm>
+          <a:prstGeom prst="rect">
+            <a:avLst/>
+          </a:prstGeom>
+          <a:noFill/>
+          <a:ln>
+            <a:noFill/>
+          </a:ln>
+        </p:spPr>
+        <p:txBody>
+          <a:bodyPr wrap="square" lIns="0" tIns="0" rIns="0" bIns="0" anchor="t" rtlCol="0">
+            <a:spAutoFit/>
+          </a:bodyPr>
+          <a:lstStyle/>
+          <a:p>
+            <a:pPr algn="l" marL="0" indent="0">
+              <a:lnSpc>
+                <a:spcPct val="100000"/>
+              </a:lnSpc>
+              <a:spcBef>
+                <a:spcPts val="0"/>
+              </a:spcBef>
+              <a:spcAft>
+                <a:spcPts val="0"/>
+              </a:spcAft>
+              <a:buNone/>
+            </a:pPr>
+            <a:r>
+              <a:rPr lang="en-US" sz="1300" b="1" i="0" u="none" strike="noStrike" dirty="0">
+                <a:solidFill>
+                  <a:srgbClr val="FFFFFF"/>
+                </a:solidFill>
+                <a:latin typeface="Calibri"/>
+                <a:cs typeface="Calibri"/>
+              </a:rPr>
+              <a:t>THREE APPS. ONE OPEN SOURCE SUITE.</a:t>
+            </a:r>
+            <a:endParaRPr lang="en-US" sz="1300" b="1" i="0" u="none" strike="noStrike" dirty="0">
               <a:solidFill>
                 <a:srgbClr val="FFFFFF"/>
               </a:solidFill>
@@ -3026,7 +3347,7 @@
       </p:grpSpPr>
       <p:sp>
         <p:nvSpPr>
-          <p:cNvPr id="2" name="TextBox 19"/>
+          <p:cNvPr id="2" name="TextBox 25"/>
           <p:cNvSpPr txBox="1"/>
           <p:nvPr/>
         </p:nvSpPr>
@@ -3083,7 +3404,7 @@
       </p:sp>
       <p:sp>
         <p:nvSpPr>
-          <p:cNvPr id="3" name="TextBox 20"/>
+          <p:cNvPr id="3" name="TextBox 26"/>
           <p:cNvSpPr txBox="1"/>
           <p:nvPr/>
         </p:nvSpPr>
@@ -3171,7 +3492,7 @@
       </p:sp>
       <p:sp>
         <p:nvSpPr>
-          <p:cNvPr id="4" name="TextBox 21"/>
+          <p:cNvPr id="4" name="TextBox 27"/>
           <p:cNvSpPr txBox="1"/>
           <p:nvPr/>
         </p:nvSpPr>
@@ -3259,7 +3580,7 @@
       </p:sp>
       <p:pic>
         <p:nvPicPr>
-          <p:cNvPr id="5" name="Picture 22"/>
+          <p:cNvPr id="5" name="Picture 28"/>
           <p:cNvPicPr>
             <a:picLocks noChangeAspect="1"/>
           </p:cNvPicPr>
@@ -3283,7 +3604,7 @@
       </p:pic>
       <p:sp>
         <p:nvSpPr>
-          <p:cNvPr id="6" name="TextBox 23"/>
+          <p:cNvPr id="6" name="TextBox 29"/>
           <p:cNvSpPr txBox="1"/>
           <p:nvPr/>
         </p:nvSpPr>
@@ -3350,6 +3671,2394 @@
 </file>
 
 <file path=ppt/slides/slide3.xml><?xml version="1.0" encoding="utf-8"?>
+<p:sld xmlns:a="http://schemas.openxmlformats.org/drawingml/2006/main" xmlns:r="http://schemas.openxmlformats.org/officeDocument/2006/relationships" xmlns:p="http://schemas.openxmlformats.org/presentationml/2006/main">
+  <p:cSld>
+    <p:bg>
+      <p:bgPr>
+        <a:solidFill>
+          <a:srgbClr val="FFF3ED"/>
+        </a:solidFill>
+        <a:effectLst/>
+      </p:bgPr>
+    </p:bg>
+    <p:spTree>
+      <p:nvGrpSpPr>
+        <p:cNvPr id="1" name=""/>
+        <p:cNvGrpSpPr/>
+        <p:nvPr/>
+      </p:nvGrpSpPr>
+      <p:grpSpPr>
+        <a:xfrm>
+          <a:off x="0" y="0"/>
+          <a:ext cx="0" cy="0"/>
+          <a:chOff x="0" y="0"/>
+          <a:chExt cx="0" cy="0"/>
+        </a:xfrm>
+      </p:grpSpPr>
+      <p:sp>
+        <p:nvSpPr>
+          <p:cNvPr id="2" name="TextBox 31"/>
+          <p:cNvSpPr txBox="1"/>
+          <p:nvPr/>
+        </p:nvSpPr>
+        <p:spPr>
+          <a:xfrm>
+            <a:off x="406400" y="508000"/>
+            <a:ext cx="4902200" cy="8636000"/>
+          </a:xfrm>
+          <a:prstGeom prst="rect">
+            <a:avLst/>
+          </a:prstGeom>
+          <a:noFill/>
+          <a:ln>
+            <a:noFill/>
+          </a:ln>
+        </p:spPr>
+        <p:txBody>
+          <a:bodyPr wrap="square" lIns="0" tIns="0" rIns="0" bIns="0" anchor="t" rtlCol="0">
+            <a:spAutoFit/>
+          </a:bodyPr>
+          <a:lstStyle/>
+          <a:p>
+            <a:pPr algn="l" marL="0" indent="0">
+              <a:lnSpc>
+                <a:spcPct val="100000"/>
+              </a:lnSpc>
+              <a:spcBef>
+                <a:spcPts val="0"/>
+              </a:spcBef>
+              <a:spcAft>
+                <a:spcPts val="0"/>
+              </a:spcAft>
+              <a:buNone/>
+            </a:pPr>
+            <a:r>
+              <a:rPr lang="en-US" sz="1300" b="1" i="0" u="none" strike="noStrike" dirty="0">
+                <a:solidFill>
+                  <a:srgbClr val="C74724"/>
+                </a:solidFill>
+                <a:latin typeface="Calibri"/>
+                <a:cs typeface="Calibri"/>
+              </a:rPr>
+              <a:t>02  /  MEET SLIDES</a:t>
+            </a:r>
+            <a:endParaRPr lang="en-US" sz="1300" b="1" i="0" u="none" strike="noStrike" dirty="0">
+              <a:solidFill>
+                <a:srgbClr val="C74724"/>
+              </a:solidFill>
+              <a:latin typeface="Calibri"/>
+              <a:cs typeface="Calibri"/>
+            </a:endParaRPr>
+          </a:p>
+        </p:txBody>
+      </p:sp>
+      <p:sp>
+        <p:nvSpPr>
+          <p:cNvPr id="3" name="TextBox 32"/>
+          <p:cNvSpPr txBox="1"/>
+          <p:nvPr/>
+        </p:nvSpPr>
+        <p:spPr>
+          <a:xfrm>
+            <a:off x="406400" y="1193800"/>
+            <a:ext cx="5080000" cy="7950200"/>
+          </a:xfrm>
+          <a:prstGeom prst="rect">
+            <a:avLst/>
+          </a:prstGeom>
+          <a:noFill/>
+          <a:ln>
+            <a:noFill/>
+          </a:ln>
+        </p:spPr>
+        <p:txBody>
+          <a:bodyPr wrap="square" lIns="0" tIns="0" rIns="0" bIns="0" anchor="t" rtlCol="0">
+            <a:spAutoFit/>
+          </a:bodyPr>
+          <a:lstStyle/>
+          <a:p>
+            <a:pPr algn="l" marL="0" indent="0">
+              <a:lnSpc>
+                <a:spcPct val="100000"/>
+              </a:lnSpc>
+              <a:spcBef>
+                <a:spcPts val="0"/>
+              </a:spcBef>
+              <a:spcAft>
+                <a:spcPts val="0"/>
+              </a:spcAft>
+              <a:buNone/>
+            </a:pPr>
+            <a:r>
+              <a:rPr lang="en-US" sz="6600" b="1" i="0" u="none" strike="noStrike" dirty="0">
+                <a:solidFill>
+                  <a:srgbClr val="132442"/>
+                </a:solidFill>
+                <a:latin typeface="Calibri"/>
+                <a:cs typeface="Calibri"/>
+              </a:rPr>
+              <a:t>Make your</a:t>
+            </a:r>
+            <a:endParaRPr lang="en-US" sz="6600" b="1" i="0" u="none" strike="noStrike" dirty="0">
+              <a:solidFill>
+                <a:srgbClr val="132442"/>
+              </a:solidFill>
+              <a:latin typeface="Calibri"/>
+              <a:cs typeface="Calibri"/>
+            </a:endParaRPr>
+          </a:p>
+          <a:p>
+            <a:pPr algn="l" marL="0" indent="0">
+              <a:lnSpc>
+                <a:spcPct val="100000"/>
+              </a:lnSpc>
+              <a:spcBef>
+                <a:spcPts val="0"/>
+              </a:spcBef>
+              <a:spcAft>
+                <a:spcPts val="0"/>
+              </a:spcAft>
+              <a:buNone/>
+            </a:pPr>
+            <a:r>
+              <a:rPr lang="en-US" sz="6600" b="1" i="0" u="none" strike="noStrike" dirty="0">
+                <a:solidFill>
+                  <a:srgbClr val="132442"/>
+                </a:solidFill>
+                <a:latin typeface="Calibri"/>
+                <a:cs typeface="Calibri"/>
+              </a:rPr>
+              <a:t>point.</a:t>
+            </a:r>
+            <a:endParaRPr lang="en-US" sz="6600" b="1" i="0" u="none" strike="noStrike" dirty="0">
+              <a:solidFill>
+                <a:srgbClr val="132442"/>
+              </a:solidFill>
+              <a:latin typeface="Calibri"/>
+              <a:cs typeface="Calibri"/>
+            </a:endParaRPr>
+          </a:p>
+        </p:txBody>
+      </p:sp>
+      <p:sp>
+        <p:nvSpPr>
+          <p:cNvPr id="4" name="TextBox 33"/>
+          <p:cNvSpPr txBox="1"/>
+          <p:nvPr/>
+        </p:nvSpPr>
+        <p:spPr>
+          <a:xfrm>
+            <a:off x="406400" y="7239000"/>
+            <a:ext cx="4953000" cy="1905000"/>
+          </a:xfrm>
+          <a:prstGeom prst="rect">
+            <a:avLst/>
+          </a:prstGeom>
+          <a:noFill/>
+          <a:ln>
+            <a:noFill/>
+          </a:ln>
+        </p:spPr>
+        <p:txBody>
+          <a:bodyPr wrap="square" lIns="0" tIns="0" rIns="0" bIns="0" anchor="t" rtlCol="0">
+            <a:spAutoFit/>
+          </a:bodyPr>
+          <a:lstStyle/>
+          <a:p>
+            <a:pPr algn="l" marL="0" indent="0">
+              <a:lnSpc>
+                <a:spcPct val="100000"/>
+              </a:lnSpc>
+              <a:spcBef>
+                <a:spcPts val="0"/>
+              </a:spcBef>
+              <a:spcAft>
+                <a:spcPts val="0"/>
+              </a:spcAft>
+              <a:buNone/>
+            </a:pPr>
+            <a:r>
+              <a:rPr lang="en-US" sz="2100" b="0" i="0" u="none" strike="noStrike" dirty="0">
+                <a:solidFill>
+                  <a:srgbClr val="536782"/>
+                </a:solidFill>
+                <a:latin typeface="Calibri"/>
+                <a:cs typeface="Calibri"/>
+              </a:rPr>
+              <a:t>Build a deck. Tell your story.</a:t>
+            </a:r>
+            <a:endParaRPr lang="en-US" sz="2100" b="0" i="0" u="none" strike="noStrike" dirty="0">
+              <a:solidFill>
+                <a:srgbClr val="536782"/>
+              </a:solidFill>
+              <a:latin typeface="Calibri"/>
+              <a:cs typeface="Calibri"/>
+            </a:endParaRPr>
+          </a:p>
+          <a:p>
+            <a:pPr algn="l" marL="0" indent="0">
+              <a:lnSpc>
+                <a:spcPct val="100000"/>
+              </a:lnSpc>
+              <a:spcBef>
+                <a:spcPts val="0"/>
+              </a:spcBef>
+              <a:spcAft>
+                <a:spcPts val="0"/>
+              </a:spcAft>
+              <a:buNone/>
+            </a:pPr>
+            <a:r>
+              <a:rPr lang="en-US" sz="2100" b="0" i="0" u="none" strike="noStrike" dirty="0">
+                <a:solidFill>
+                  <a:srgbClr val="536782"/>
+                </a:solidFill>
+                <a:latin typeface="Calibri"/>
+                <a:cs typeface="Calibri"/>
+              </a:rPr>
+              <a:t>Present it with confidence.</a:t>
+            </a:r>
+            <a:endParaRPr lang="en-US" sz="2100" b="0" i="0" u="none" strike="noStrike" dirty="0">
+              <a:solidFill>
+                <a:srgbClr val="536782"/>
+              </a:solidFill>
+              <a:latin typeface="Calibri"/>
+              <a:cs typeface="Calibri"/>
+            </a:endParaRPr>
+          </a:p>
+        </p:txBody>
+      </p:sp>
+      <p:sp>
+        <p:nvSpPr>
+          <p:cNvPr id="5" name="Rounded Rectangle 34"/>
+          <p:cNvSpPr/>
+          <p:nvPr/>
+        </p:nvSpPr>
+        <p:spPr>
+          <a:xfrm>
+            <a:off x="406400" y="3606800"/>
+            <a:ext cx="4902200" cy="3130967"/>
+          </a:xfrm>
+          <a:prstGeom prst="roundRect">
+            <a:avLst/>
+          </a:prstGeom>
+          <a:solidFill>
+            <a:srgbClr val="FFFFFF"/>
+          </a:solidFill>
+          <a:ln>
+            <a:noFill/>
+          </a:ln>
+        </p:spPr>
+        <p:txBody>
+          <a:bodyPr wrap="square" lIns="91440" tIns="45720" rIns="91440" bIns="45720" anchor="ctr" rtlCol="0">
+            <a:noAutofit/>
+          </a:bodyPr>
+          <a:lstStyle/>
+          <a:p>
+            <a:pPr algn="ctr" marL="0" indent="0">
+              <a:lnSpc>
+                <a:spcPct val="100000"/>
+              </a:lnSpc>
+              <a:spcBef>
+                <a:spcPts val="0"/>
+              </a:spcBef>
+              <a:spcAft>
+                <a:spcPts val="0"/>
+              </a:spcAft>
+              <a:buNone/>
+            </a:pPr>
+            <a:endParaRPr lang="en-US" sz="1800" b="0" i="0" u="none" strike="noStrike" dirty="0">
+              <a:solidFill>
+                <a:srgbClr val="FFFFFF"/>
+              </a:solidFill>
+              <a:latin typeface="Calibri"/>
+              <a:cs typeface="Calibri"/>
+            </a:endParaRPr>
+          </a:p>
+        </p:txBody>
+      </p:sp>
+      <p:sp>
+        <p:nvSpPr>
+          <p:cNvPr id="6" name="TextBox 35"/>
+          <p:cNvSpPr txBox="1"/>
+          <p:nvPr/>
+        </p:nvSpPr>
+        <p:spPr>
+          <a:xfrm>
+            <a:off x="719497" y="3848332"/>
+            <a:ext cx="4249170" cy="5295668"/>
+          </a:xfrm>
+          <a:prstGeom prst="rect">
+            <a:avLst/>
+          </a:prstGeom>
+          <a:noFill/>
+          <a:ln>
+            <a:noFill/>
+          </a:ln>
+        </p:spPr>
+        <p:txBody>
+          <a:bodyPr wrap="square" lIns="0" tIns="0" rIns="0" bIns="0" anchor="t" rtlCol="0">
+            <a:spAutoFit/>
+          </a:bodyPr>
+          <a:lstStyle/>
+          <a:p>
+            <a:pPr algn="l" marL="0" indent="0">
+              <a:lnSpc>
+                <a:spcPct val="100000"/>
+              </a:lnSpc>
+              <a:spcBef>
+                <a:spcPts val="0"/>
+              </a:spcBef>
+              <a:spcAft>
+                <a:spcPts val="0"/>
+              </a:spcAft>
+              <a:buNone/>
+            </a:pPr>
+            <a:r>
+              <a:rPr lang="en-US" sz="2958" b="1" i="0" u="none" strike="noStrike" dirty="0">
+                <a:solidFill>
+                  <a:srgbClr val="132442"/>
+                </a:solidFill>
+                <a:latin typeface="Calibri"/>
+                <a:cs typeface="Calibri"/>
+              </a:rPr>
+              <a:t>A clear idea.</a:t>
+            </a:r>
+            <a:endParaRPr lang="en-US" sz="2958" b="1" i="0" u="none" strike="noStrike" dirty="0">
+              <a:solidFill>
+                <a:srgbClr val="132442"/>
+              </a:solidFill>
+              <a:latin typeface="Calibri"/>
+              <a:cs typeface="Calibri"/>
+            </a:endParaRPr>
+          </a:p>
+        </p:txBody>
+      </p:sp>
+      <p:sp>
+        <p:nvSpPr>
+          <p:cNvPr id="7" name="TextBox 36"/>
+          <p:cNvSpPr txBox="1"/>
+          <p:nvPr/>
+        </p:nvSpPr>
+        <p:spPr>
+          <a:xfrm>
+            <a:off x="719497" y="4420851"/>
+            <a:ext cx="4249170" cy="4723149"/>
+          </a:xfrm>
+          <a:prstGeom prst="rect">
+            <a:avLst/>
+          </a:prstGeom>
+          <a:noFill/>
+          <a:ln>
+            <a:noFill/>
+          </a:ln>
+        </p:spPr>
+        <p:txBody>
+          <a:bodyPr wrap="square" lIns="0" tIns="0" rIns="0" bIns="0" anchor="t" rtlCol="0">
+            <a:spAutoFit/>
+          </a:bodyPr>
+          <a:lstStyle/>
+          <a:p>
+            <a:pPr algn="l" marL="0" indent="0">
+              <a:lnSpc>
+                <a:spcPct val="100000"/>
+              </a:lnSpc>
+              <a:spcBef>
+                <a:spcPts val="0"/>
+              </a:spcBef>
+              <a:spcAft>
+                <a:spcPts val="0"/>
+              </a:spcAft>
+              <a:buNone/>
+            </a:pPr>
+            <a:r>
+              <a:rPr lang="en-US" sz="1057" b="1" i="0" u="none" strike="noStrike" dirty="0">
+                <a:solidFill>
+                  <a:srgbClr val="C74724"/>
+                </a:solidFill>
+                <a:latin typeface="Calibri"/>
+                <a:cs typeface="Calibri"/>
+              </a:rPr>
+              <a:t>MAKE EVERY SLIDE COUNT</a:t>
+            </a:r>
+            <a:endParaRPr lang="en-US" sz="1057" b="1" i="0" u="none" strike="noStrike" dirty="0">
+              <a:solidFill>
+                <a:srgbClr val="C74724"/>
+              </a:solidFill>
+              <a:latin typeface="Calibri"/>
+              <a:cs typeface="Calibri"/>
+            </a:endParaRPr>
+          </a:p>
+        </p:txBody>
+      </p:sp>
+      <p:sp>
+        <p:nvSpPr>
+          <p:cNvPr id="8" name="Rounded Rectangle 37"/>
+          <p:cNvSpPr/>
+          <p:nvPr/>
+        </p:nvSpPr>
+        <p:spPr>
+          <a:xfrm>
+            <a:off x="782116" y="5610619"/>
+            <a:ext cx="554628" cy="626193"/>
+          </a:xfrm>
+          <a:prstGeom prst="roundRect">
+            <a:avLst/>
+          </a:prstGeom>
+          <a:solidFill>
+            <a:srgbClr val="FFCBB8"/>
+          </a:solidFill>
+          <a:ln>
+            <a:noFill/>
+          </a:ln>
+        </p:spPr>
+        <p:txBody>
+          <a:bodyPr wrap="square" lIns="91440" tIns="45720" rIns="91440" bIns="45720" anchor="ctr" rtlCol="0">
+            <a:noAutofit/>
+          </a:bodyPr>
+          <a:lstStyle/>
+          <a:p>
+            <a:pPr algn="ctr" marL="0" indent="0">
+              <a:lnSpc>
+                <a:spcPct val="100000"/>
+              </a:lnSpc>
+              <a:spcBef>
+                <a:spcPts val="0"/>
+              </a:spcBef>
+              <a:spcAft>
+                <a:spcPts val="0"/>
+              </a:spcAft>
+              <a:buNone/>
+            </a:pPr>
+            <a:endParaRPr lang="en-US" sz="1800" b="0" i="0" u="none" strike="noStrike" dirty="0">
+              <a:solidFill>
+                <a:srgbClr val="FFFFFF"/>
+              </a:solidFill>
+              <a:latin typeface="Calibri"/>
+              <a:cs typeface="Calibri"/>
+            </a:endParaRPr>
+          </a:p>
+        </p:txBody>
+      </p:sp>
+      <p:sp>
+        <p:nvSpPr>
+          <p:cNvPr id="9" name="Rounded Rectangle 38"/>
+          <p:cNvSpPr/>
+          <p:nvPr/>
+        </p:nvSpPr>
+        <p:spPr>
+          <a:xfrm>
+            <a:off x="1605113" y="5225957"/>
+            <a:ext cx="554628" cy="1010855"/>
+          </a:xfrm>
+          <a:prstGeom prst="roundRect">
+            <a:avLst/>
+          </a:prstGeom>
+          <a:solidFill>
+            <a:srgbClr val="F2906D"/>
+          </a:solidFill>
+          <a:ln>
+            <a:noFill/>
+          </a:ln>
+        </p:spPr>
+        <p:txBody>
+          <a:bodyPr wrap="square" lIns="91440" tIns="45720" rIns="91440" bIns="45720" anchor="ctr" rtlCol="0">
+            <a:noAutofit/>
+          </a:bodyPr>
+          <a:lstStyle/>
+          <a:p>
+            <a:pPr algn="ctr" marL="0" indent="0">
+              <a:lnSpc>
+                <a:spcPct val="100000"/>
+              </a:lnSpc>
+              <a:spcBef>
+                <a:spcPts val="0"/>
+              </a:spcBef>
+              <a:spcAft>
+                <a:spcPts val="0"/>
+              </a:spcAft>
+              <a:buNone/>
+            </a:pPr>
+            <a:endParaRPr lang="en-US" sz="1800" b="0" i="0" u="none" strike="noStrike" dirty="0">
+              <a:solidFill>
+                <a:srgbClr val="FFFFFF"/>
+              </a:solidFill>
+              <a:latin typeface="Calibri"/>
+              <a:cs typeface="Calibri"/>
+            </a:endParaRPr>
+          </a:p>
+        </p:txBody>
+      </p:sp>
+      <p:sp>
+        <p:nvSpPr>
+          <p:cNvPr id="10" name="Rounded Rectangle 39"/>
+          <p:cNvSpPr/>
+          <p:nvPr/>
+        </p:nvSpPr>
+        <p:spPr>
+          <a:xfrm>
+            <a:off x="2428110" y="4769731"/>
+            <a:ext cx="554628" cy="1467082"/>
+          </a:xfrm>
+          <a:prstGeom prst="roundRect">
+            <a:avLst/>
+          </a:prstGeom>
+          <a:solidFill>
+            <a:srgbClr val="C74724"/>
+          </a:solidFill>
+          <a:ln>
+            <a:noFill/>
+          </a:ln>
+        </p:spPr>
+        <p:txBody>
+          <a:bodyPr wrap="square" lIns="91440" tIns="45720" rIns="91440" bIns="45720" anchor="ctr" rtlCol="0">
+            <a:noAutofit/>
+          </a:bodyPr>
+          <a:lstStyle/>
+          <a:p>
+            <a:pPr algn="ctr" marL="0" indent="0">
+              <a:lnSpc>
+                <a:spcPct val="100000"/>
+              </a:lnSpc>
+              <a:spcBef>
+                <a:spcPts val="0"/>
+              </a:spcBef>
+              <a:spcAft>
+                <a:spcPts val="0"/>
+              </a:spcAft>
+              <a:buNone/>
+            </a:pPr>
+            <a:endParaRPr lang="en-US" sz="1800" b="0" i="0" u="none" strike="noStrike" dirty="0">
+              <a:solidFill>
+                <a:srgbClr val="FFFFFF"/>
+              </a:solidFill>
+              <a:latin typeface="Calibri"/>
+              <a:cs typeface="Calibri"/>
+            </a:endParaRPr>
+          </a:p>
+        </p:txBody>
+      </p:sp>
+      <p:sp>
+        <p:nvSpPr>
+          <p:cNvPr id="11" name="TextBox 40"/>
+          <p:cNvSpPr txBox="1"/>
+          <p:nvPr/>
+        </p:nvSpPr>
+        <p:spPr>
+          <a:xfrm>
+            <a:off x="3483693" y="5127555"/>
+            <a:ext cx="1654940" cy="4016445"/>
+          </a:xfrm>
+          <a:prstGeom prst="rect">
+            <a:avLst/>
+          </a:prstGeom>
+          <a:noFill/>
+          <a:ln>
+            <a:noFill/>
+          </a:ln>
+        </p:spPr>
+        <p:txBody>
+          <a:bodyPr wrap="square" lIns="0" tIns="0" rIns="0" bIns="0" anchor="t" rtlCol="0">
+            <a:spAutoFit/>
+          </a:bodyPr>
+          <a:lstStyle/>
+          <a:p>
+            <a:pPr algn="l" marL="0" indent="0">
+              <a:lnSpc>
+                <a:spcPct val="100000"/>
+              </a:lnSpc>
+              <a:spcBef>
+                <a:spcPts val="0"/>
+              </a:spcBef>
+              <a:spcAft>
+                <a:spcPts val="0"/>
+              </a:spcAft>
+              <a:buNone/>
+            </a:pPr>
+            <a:r>
+              <a:rPr lang="en-US" sz="1268" b="1" i="0" u="none" strike="noStrike" dirty="0">
+                <a:solidFill>
+                  <a:srgbClr val="536782"/>
+                </a:solidFill>
+                <a:latin typeface="Calibri"/>
+                <a:cs typeface="Calibri"/>
+              </a:rPr>
+              <a:t>Clear message</a:t>
+            </a:r>
+            <a:endParaRPr lang="en-US" sz="1268" b="1" i="0" u="none" strike="noStrike" dirty="0">
+              <a:solidFill>
+                <a:srgbClr val="536782"/>
+              </a:solidFill>
+              <a:latin typeface="Calibri"/>
+              <a:cs typeface="Calibri"/>
+            </a:endParaRPr>
+          </a:p>
+        </p:txBody>
+      </p:sp>
+      <p:sp>
+        <p:nvSpPr>
+          <p:cNvPr id="12" name="TextBox 41"/>
+          <p:cNvSpPr txBox="1"/>
+          <p:nvPr/>
+        </p:nvSpPr>
+        <p:spPr>
+          <a:xfrm>
+            <a:off x="3483693" y="5512217"/>
+            <a:ext cx="1654940" cy="3631783"/>
+          </a:xfrm>
+          <a:prstGeom prst="rect">
+            <a:avLst/>
+          </a:prstGeom>
+          <a:noFill/>
+          <a:ln>
+            <a:noFill/>
+          </a:ln>
+        </p:spPr>
+        <p:txBody>
+          <a:bodyPr wrap="square" lIns="0" tIns="0" rIns="0" bIns="0" anchor="t" rtlCol="0">
+            <a:spAutoFit/>
+          </a:bodyPr>
+          <a:lstStyle/>
+          <a:p>
+            <a:pPr algn="l" marL="0" indent="0">
+              <a:lnSpc>
+                <a:spcPct val="100000"/>
+              </a:lnSpc>
+              <a:spcBef>
+                <a:spcPts val="0"/>
+              </a:spcBef>
+              <a:spcAft>
+                <a:spcPts val="0"/>
+              </a:spcAft>
+              <a:buNone/>
+            </a:pPr>
+            <a:r>
+              <a:rPr lang="en-US" sz="1268" b="0" i="0" u="none" strike="noStrike" dirty="0">
+                <a:solidFill>
+                  <a:srgbClr val="536782"/>
+                </a:solidFill>
+                <a:latin typeface="Calibri"/>
+                <a:cs typeface="Calibri"/>
+              </a:rPr>
+              <a:t>Strong visuals</a:t>
+            </a:r>
+            <a:endParaRPr lang="en-US" sz="1268" b="0" i="0" u="none" strike="noStrike" dirty="0">
+              <a:solidFill>
+                <a:srgbClr val="536782"/>
+              </a:solidFill>
+              <a:latin typeface="Calibri"/>
+              <a:cs typeface="Calibri"/>
+            </a:endParaRPr>
+          </a:p>
+        </p:txBody>
+      </p:sp>
+      <p:sp>
+        <p:nvSpPr>
+          <p:cNvPr id="13" name="TextBox 42"/>
+          <p:cNvSpPr txBox="1"/>
+          <p:nvPr/>
+        </p:nvSpPr>
+        <p:spPr>
+          <a:xfrm>
+            <a:off x="3483693" y="5896879"/>
+            <a:ext cx="1654940" cy="3247121"/>
+          </a:xfrm>
+          <a:prstGeom prst="rect">
+            <a:avLst/>
+          </a:prstGeom>
+          <a:noFill/>
+          <a:ln>
+            <a:noFill/>
+          </a:ln>
+        </p:spPr>
+        <p:txBody>
+          <a:bodyPr wrap="square" lIns="0" tIns="0" rIns="0" bIns="0" anchor="t" rtlCol="0">
+            <a:spAutoFit/>
+          </a:bodyPr>
+          <a:lstStyle/>
+          <a:p>
+            <a:pPr algn="l" marL="0" indent="0">
+              <a:lnSpc>
+                <a:spcPct val="100000"/>
+              </a:lnSpc>
+              <a:spcBef>
+                <a:spcPts val="0"/>
+              </a:spcBef>
+              <a:spcAft>
+                <a:spcPts val="0"/>
+              </a:spcAft>
+              <a:buNone/>
+            </a:pPr>
+            <a:r>
+              <a:rPr lang="en-US" sz="1268" b="0" i="0" u="none" strike="noStrike" dirty="0">
+                <a:solidFill>
+                  <a:srgbClr val="536782"/>
+                </a:solidFill>
+                <a:latin typeface="Calibri"/>
+                <a:cs typeface="Calibri"/>
+              </a:rPr>
+              <a:t>Your next big idea</a:t>
+            </a:r>
+            <a:endParaRPr lang="en-US" sz="1268" b="0" i="0" u="none" strike="noStrike" dirty="0">
+              <a:solidFill>
+                <a:srgbClr val="536782"/>
+              </a:solidFill>
+              <a:latin typeface="Calibri"/>
+              <a:cs typeface="Calibri"/>
+            </a:endParaRPr>
+          </a:p>
+        </p:txBody>
+      </p:sp>
+      <p:sp>
+        <p:nvSpPr>
+          <p:cNvPr id="14" name="TextBox 43"/>
+          <p:cNvSpPr txBox="1"/>
+          <p:nvPr/>
+        </p:nvSpPr>
+        <p:spPr>
+          <a:xfrm>
+            <a:off x="406400" y="8305800"/>
+            <a:ext cx="4902200" cy="838200"/>
+          </a:xfrm>
+          <a:prstGeom prst="rect">
+            <a:avLst/>
+          </a:prstGeom>
+          <a:noFill/>
+          <a:ln>
+            <a:noFill/>
+          </a:ln>
+        </p:spPr>
+        <p:txBody>
+          <a:bodyPr wrap="square" lIns="0" tIns="0" rIns="0" bIns="0" anchor="t" rtlCol="0">
+            <a:spAutoFit/>
+          </a:bodyPr>
+          <a:lstStyle/>
+          <a:p>
+            <a:pPr algn="l" marL="0" indent="0">
+              <a:lnSpc>
+                <a:spcPct val="100000"/>
+              </a:lnSpc>
+              <a:spcBef>
+                <a:spcPts val="0"/>
+              </a:spcBef>
+              <a:spcAft>
+                <a:spcPts val="0"/>
+              </a:spcAft>
+              <a:buNone/>
+            </a:pPr>
+            <a:r>
+              <a:rPr lang="en-US" sz="1200" b="1" i="0" u="none" strike="noStrike" dirty="0">
+                <a:solidFill>
+                  <a:srgbClr val="C74724"/>
+                </a:solidFill>
+                <a:latin typeface="Calibri"/>
+                <a:cs typeface="Calibri"/>
+              </a:rPr>
+              <a:t>PPTX  ·  THEMES  ·  CHARTS  ·  ANIMATIONS</a:t>
+            </a:r>
+            <a:endParaRPr lang="en-US" sz="1200" b="1" i="0" u="none" strike="noStrike" dirty="0">
+              <a:solidFill>
+                <a:srgbClr val="C74724"/>
+              </a:solidFill>
+              <a:latin typeface="Calibri"/>
+              <a:cs typeface="Calibri"/>
+            </a:endParaRPr>
+          </a:p>
+        </p:txBody>
+      </p:sp>
+    </p:spTree>
+  </p:cSld>
+  <p:clrMapOvr>
+    <a:masterClrMapping/>
+  </p:clrMapOvr>
+  <p:transition spd="fast">
+    <p:fade/>
+  </p:transition>
+</p:sld>
+</file>
+
+<file path=ppt/slides/slide4.xml><?xml version="1.0" encoding="utf-8"?>
+<p:sld xmlns:a="http://schemas.openxmlformats.org/drawingml/2006/main" xmlns:r="http://schemas.openxmlformats.org/officeDocument/2006/relationships" xmlns:p="http://schemas.openxmlformats.org/presentationml/2006/main">
+  <p:cSld>
+    <p:bg>
+      <p:bgPr>
+        <a:solidFill>
+          <a:srgbClr val="EDF9F2"/>
+        </a:solidFill>
+        <a:effectLst/>
+      </p:bgPr>
+    </p:bg>
+    <p:spTree>
+      <p:nvGrpSpPr>
+        <p:cNvPr id="1" name=""/>
+        <p:cNvGrpSpPr/>
+        <p:nvPr/>
+      </p:nvGrpSpPr>
+      <p:grpSpPr>
+        <a:xfrm>
+          <a:off x="0" y="0"/>
+          <a:ext cx="0" cy="0"/>
+          <a:chOff x="0" y="0"/>
+          <a:chExt cx="0" cy="0"/>
+        </a:xfrm>
+      </p:grpSpPr>
+      <p:sp>
+        <p:nvSpPr>
+          <p:cNvPr id="2" name="TextBox 45"/>
+          <p:cNvSpPr txBox="1"/>
+          <p:nvPr/>
+        </p:nvSpPr>
+        <p:spPr>
+          <a:xfrm>
+            <a:off x="406400" y="508000"/>
+            <a:ext cx="4902200" cy="8636000"/>
+          </a:xfrm>
+          <a:prstGeom prst="rect">
+            <a:avLst/>
+          </a:prstGeom>
+          <a:noFill/>
+          <a:ln>
+            <a:noFill/>
+          </a:ln>
+        </p:spPr>
+        <p:txBody>
+          <a:bodyPr wrap="square" lIns="0" tIns="0" rIns="0" bIns="0" anchor="t" rtlCol="0">
+            <a:spAutoFit/>
+          </a:bodyPr>
+          <a:lstStyle/>
+          <a:p>
+            <a:pPr algn="l" marL="0" indent="0">
+              <a:lnSpc>
+                <a:spcPct val="100000"/>
+              </a:lnSpc>
+              <a:spcBef>
+                <a:spcPts val="0"/>
+              </a:spcBef>
+              <a:spcAft>
+                <a:spcPts val="0"/>
+              </a:spcAft>
+              <a:buNone/>
+            </a:pPr>
+            <a:r>
+              <a:rPr lang="en-US" sz="1300" b="1" i="0" u="none" strike="noStrike" dirty="0">
+                <a:solidFill>
+                  <a:srgbClr val="13794D"/>
+                </a:solidFill>
+                <a:latin typeface="Calibri"/>
+                <a:cs typeface="Calibri"/>
+              </a:rPr>
+              <a:t>03  /  MEET SHEETS</a:t>
+            </a:r>
+            <a:endParaRPr lang="en-US" sz="1300" b="1" i="0" u="none" strike="noStrike" dirty="0">
+              <a:solidFill>
+                <a:srgbClr val="13794D"/>
+              </a:solidFill>
+              <a:latin typeface="Calibri"/>
+              <a:cs typeface="Calibri"/>
+            </a:endParaRPr>
+          </a:p>
+        </p:txBody>
+      </p:sp>
+      <p:sp>
+        <p:nvSpPr>
+          <p:cNvPr id="3" name="TextBox 46"/>
+          <p:cNvSpPr txBox="1"/>
+          <p:nvPr/>
+        </p:nvSpPr>
+        <p:spPr>
+          <a:xfrm>
+            <a:off x="406400" y="1193800"/>
+            <a:ext cx="5080000" cy="7950200"/>
+          </a:xfrm>
+          <a:prstGeom prst="rect">
+            <a:avLst/>
+          </a:prstGeom>
+          <a:noFill/>
+          <a:ln>
+            <a:noFill/>
+          </a:ln>
+        </p:spPr>
+        <p:txBody>
+          <a:bodyPr wrap="square" lIns="0" tIns="0" rIns="0" bIns="0" anchor="t" rtlCol="0">
+            <a:spAutoFit/>
+          </a:bodyPr>
+          <a:lstStyle/>
+          <a:p>
+            <a:pPr algn="l" marL="0" indent="0">
+              <a:lnSpc>
+                <a:spcPct val="100000"/>
+              </a:lnSpc>
+              <a:spcBef>
+                <a:spcPts val="0"/>
+              </a:spcBef>
+              <a:spcAft>
+                <a:spcPts val="0"/>
+              </a:spcAft>
+              <a:buNone/>
+            </a:pPr>
+            <a:r>
+              <a:rPr lang="en-US" sz="4800" b="1" i="0" u="none" strike="noStrike" dirty="0">
+                <a:solidFill>
+                  <a:srgbClr val="132442"/>
+                </a:solidFill>
+                <a:latin typeface="Calibri"/>
+                <a:cs typeface="Calibri"/>
+              </a:rPr>
+              <a:t>Let the numbers</a:t>
+            </a:r>
+            <a:endParaRPr lang="en-US" sz="4800" b="1" i="0" u="none" strike="noStrike" dirty="0">
+              <a:solidFill>
+                <a:srgbClr val="132442"/>
+              </a:solidFill>
+              <a:latin typeface="Calibri"/>
+              <a:cs typeface="Calibri"/>
+            </a:endParaRPr>
+          </a:p>
+          <a:p>
+            <a:pPr algn="l" marL="0" indent="0">
+              <a:lnSpc>
+                <a:spcPct val="100000"/>
+              </a:lnSpc>
+              <a:spcBef>
+                <a:spcPts val="0"/>
+              </a:spcBef>
+              <a:spcAft>
+                <a:spcPts val="0"/>
+              </a:spcAft>
+              <a:buNone/>
+            </a:pPr>
+            <a:r>
+              <a:rPr lang="en-US" sz="4800" b="1" i="0" u="none" strike="noStrike" dirty="0">
+                <a:solidFill>
+                  <a:srgbClr val="132442"/>
+                </a:solidFill>
+                <a:latin typeface="Calibri"/>
+                <a:cs typeface="Calibri"/>
+              </a:rPr>
+              <a:t>tell the story.</a:t>
+            </a:r>
+            <a:endParaRPr lang="en-US" sz="4800" b="1" i="0" u="none" strike="noStrike" dirty="0">
+              <a:solidFill>
+                <a:srgbClr val="132442"/>
+              </a:solidFill>
+              <a:latin typeface="Calibri"/>
+              <a:cs typeface="Calibri"/>
+            </a:endParaRPr>
+          </a:p>
+        </p:txBody>
+      </p:sp>
+      <p:sp>
+        <p:nvSpPr>
+          <p:cNvPr id="4" name="TextBox 47"/>
+          <p:cNvSpPr txBox="1"/>
+          <p:nvPr/>
+        </p:nvSpPr>
+        <p:spPr>
+          <a:xfrm>
+            <a:off x="406400" y="7239000"/>
+            <a:ext cx="4953000" cy="1905000"/>
+          </a:xfrm>
+          <a:prstGeom prst="rect">
+            <a:avLst/>
+          </a:prstGeom>
+          <a:noFill/>
+          <a:ln>
+            <a:noFill/>
+          </a:ln>
+        </p:spPr>
+        <p:txBody>
+          <a:bodyPr wrap="square" lIns="0" tIns="0" rIns="0" bIns="0" anchor="t" rtlCol="0">
+            <a:spAutoFit/>
+          </a:bodyPr>
+          <a:lstStyle/>
+          <a:p>
+            <a:pPr algn="l" marL="0" indent="0">
+              <a:lnSpc>
+                <a:spcPct val="100000"/>
+              </a:lnSpc>
+              <a:spcBef>
+                <a:spcPts val="0"/>
+              </a:spcBef>
+              <a:spcAft>
+                <a:spcPts val="0"/>
+              </a:spcAft>
+              <a:buNone/>
+            </a:pPr>
+            <a:r>
+              <a:rPr lang="en-US" sz="2200" b="0" i="0" u="none" strike="noStrike" dirty="0">
+                <a:solidFill>
+                  <a:srgbClr val="536782"/>
+                </a:solidFill>
+                <a:latin typeface="Calibri"/>
+                <a:cs typeface="Calibri"/>
+              </a:rPr>
+              <a:t>Organize your data.</a:t>
+            </a:r>
+            <a:endParaRPr lang="en-US" sz="2200" b="0" i="0" u="none" strike="noStrike" dirty="0">
+              <a:solidFill>
+                <a:srgbClr val="536782"/>
+              </a:solidFill>
+              <a:latin typeface="Calibri"/>
+              <a:cs typeface="Calibri"/>
+            </a:endParaRPr>
+          </a:p>
+          <a:p>
+            <a:pPr algn="l" marL="0" indent="0">
+              <a:lnSpc>
+                <a:spcPct val="100000"/>
+              </a:lnSpc>
+              <a:spcBef>
+                <a:spcPts val="0"/>
+              </a:spcBef>
+              <a:spcAft>
+                <a:spcPts val="0"/>
+              </a:spcAft>
+              <a:buNone/>
+            </a:pPr>
+            <a:r>
+              <a:rPr lang="en-US" sz="2200" b="0" i="0" u="none" strike="noStrike" dirty="0">
+                <a:solidFill>
+                  <a:srgbClr val="536782"/>
+                </a:solidFill>
+                <a:latin typeface="Calibri"/>
+                <a:cs typeface="Calibri"/>
+              </a:rPr>
+              <a:t>Turn formulas into answers.</a:t>
+            </a:r>
+            <a:endParaRPr lang="en-US" sz="2200" b="0" i="0" u="none" strike="noStrike" dirty="0">
+              <a:solidFill>
+                <a:srgbClr val="536782"/>
+              </a:solidFill>
+              <a:latin typeface="Calibri"/>
+              <a:cs typeface="Calibri"/>
+            </a:endParaRPr>
+          </a:p>
+        </p:txBody>
+      </p:sp>
+      <p:sp>
+        <p:nvSpPr>
+          <p:cNvPr id="5" name="Rounded Rectangle 48"/>
+          <p:cNvSpPr/>
+          <p:nvPr/>
+        </p:nvSpPr>
+        <p:spPr>
+          <a:xfrm>
+            <a:off x="406400" y="3632200"/>
+            <a:ext cx="4902200" cy="3097058"/>
+          </a:xfrm>
+          <a:prstGeom prst="roundRect">
+            <a:avLst/>
+          </a:prstGeom>
+          <a:solidFill>
+            <a:srgbClr val="FFFFFF"/>
+          </a:solidFill>
+          <a:ln>
+            <a:noFill/>
+          </a:ln>
+        </p:spPr>
+        <p:txBody>
+          <a:bodyPr wrap="square" lIns="91440" tIns="45720" rIns="91440" bIns="45720" anchor="ctr" rtlCol="0">
+            <a:noAutofit/>
+          </a:bodyPr>
+          <a:lstStyle/>
+          <a:p>
+            <a:pPr algn="ctr" marL="0" indent="0">
+              <a:lnSpc>
+                <a:spcPct val="100000"/>
+              </a:lnSpc>
+              <a:spcBef>
+                <a:spcPts val="0"/>
+              </a:spcBef>
+              <a:spcAft>
+                <a:spcPts val="0"/>
+              </a:spcAft>
+              <a:buNone/>
+            </a:pPr>
+            <a:endParaRPr lang="en-US" sz="1800" b="0" i="0" u="none" strike="noStrike" dirty="0">
+              <a:solidFill>
+                <a:srgbClr val="FFFFFF"/>
+              </a:solidFill>
+              <a:latin typeface="Calibri"/>
+              <a:cs typeface="Calibri"/>
+            </a:endParaRPr>
+          </a:p>
+        </p:txBody>
+      </p:sp>
+      <p:sp>
+        <p:nvSpPr>
+          <p:cNvPr id="6" name="Rounded Rectangle 49"/>
+          <p:cNvSpPr/>
+          <p:nvPr/>
+        </p:nvSpPr>
+        <p:spPr>
+          <a:xfrm>
+            <a:off x="547980" y="3773780"/>
+            <a:ext cx="4619040" cy="407042"/>
+          </a:xfrm>
+          <a:prstGeom prst="roundRect">
+            <a:avLst/>
+          </a:prstGeom>
+          <a:solidFill>
+            <a:srgbClr val="E3F3E9"/>
+          </a:solidFill>
+          <a:ln>
+            <a:noFill/>
+          </a:ln>
+        </p:spPr>
+        <p:txBody>
+          <a:bodyPr wrap="square" lIns="91440" tIns="45720" rIns="91440" bIns="45720" anchor="ctr" rtlCol="0">
+            <a:noAutofit/>
+          </a:bodyPr>
+          <a:lstStyle/>
+          <a:p>
+            <a:pPr algn="ctr" marL="0" indent="0">
+              <a:lnSpc>
+                <a:spcPct val="100000"/>
+              </a:lnSpc>
+              <a:spcBef>
+                <a:spcPts val="0"/>
+              </a:spcBef>
+              <a:spcAft>
+                <a:spcPts val="0"/>
+              </a:spcAft>
+              <a:buNone/>
+            </a:pPr>
+            <a:endParaRPr lang="en-US" sz="1800" b="0" i="0" u="none" strike="noStrike" dirty="0">
+              <a:solidFill>
+                <a:srgbClr val="FFFFFF"/>
+              </a:solidFill>
+              <a:latin typeface="Calibri"/>
+              <a:cs typeface="Calibri"/>
+            </a:endParaRPr>
+          </a:p>
+        </p:txBody>
+      </p:sp>
+      <p:sp>
+        <p:nvSpPr>
+          <p:cNvPr id="7" name="TextBox 50"/>
+          <p:cNvSpPr txBox="1"/>
+          <p:nvPr/>
+        </p:nvSpPr>
+        <p:spPr>
+          <a:xfrm>
+            <a:off x="689560" y="3844570"/>
+            <a:ext cx="4335881" cy="5299430"/>
+          </a:xfrm>
+          <a:prstGeom prst="rect">
+            <a:avLst/>
+          </a:prstGeom>
+          <a:noFill/>
+          <a:ln>
+            <a:noFill/>
+          </a:ln>
+        </p:spPr>
+        <p:txBody>
+          <a:bodyPr wrap="square" lIns="0" tIns="0" rIns="0" bIns="0" anchor="t" rtlCol="0">
+            <a:spAutoFit/>
+          </a:bodyPr>
+          <a:lstStyle/>
+          <a:p>
+            <a:pPr algn="l" marL="0" indent="0">
+              <a:lnSpc>
+                <a:spcPct val="100000"/>
+              </a:lnSpc>
+              <a:spcBef>
+                <a:spcPts val="0"/>
+              </a:spcBef>
+              <a:spcAft>
+                <a:spcPts val="0"/>
+              </a:spcAft>
+              <a:buNone/>
+            </a:pPr>
+            <a:r>
+              <a:rPr lang="en-US" sz="1533" b="0" i="0" u="none" strike="noStrike" dirty="0">
+                <a:solidFill>
+                  <a:srgbClr val="13794D"/>
+                </a:solidFill>
+                <a:latin typeface="Calibri"/>
+                <a:cs typeface="Calibri"/>
+              </a:rPr>
+              <a:t>fx    =SUM(C2:C4)</a:t>
+            </a:r>
+            <a:endParaRPr lang="en-US" sz="1533" b="0" i="0" u="none" strike="noStrike" dirty="0">
+              <a:solidFill>
+                <a:srgbClr val="13794D"/>
+              </a:solidFill>
+              <a:latin typeface="Calibri"/>
+              <a:cs typeface="Calibri"/>
+            </a:endParaRPr>
+          </a:p>
+        </p:txBody>
+      </p:sp>
+      <p:sp>
+        <p:nvSpPr>
+          <p:cNvPr id="8" name="Rectangle 51"/>
+          <p:cNvSpPr/>
+          <p:nvPr/>
+        </p:nvSpPr>
+        <p:spPr>
+          <a:xfrm>
+            <a:off x="547980" y="4357796"/>
+            <a:ext cx="4619040" cy="424739"/>
+          </a:xfrm>
+          <a:prstGeom prst="rect">
+            <a:avLst/>
+          </a:prstGeom>
+          <a:solidFill>
+            <a:srgbClr val="E3F3E9"/>
+          </a:solidFill>
+          <a:ln>
+            <a:noFill/>
+          </a:ln>
+        </p:spPr>
+        <p:txBody>
+          <a:bodyPr wrap="square" lIns="91440" tIns="45720" rIns="91440" bIns="45720" anchor="ctr" rtlCol="0">
+            <a:noAutofit/>
+          </a:bodyPr>
+          <a:lstStyle/>
+          <a:p>
+            <a:pPr algn="ctr" marL="0" indent="0">
+              <a:lnSpc>
+                <a:spcPct val="100000"/>
+              </a:lnSpc>
+              <a:spcBef>
+                <a:spcPts val="0"/>
+              </a:spcBef>
+              <a:spcAft>
+                <a:spcPts val="0"/>
+              </a:spcAft>
+              <a:buNone/>
+            </a:pPr>
+            <a:endParaRPr lang="en-US" sz="1800" b="0" i="0" u="none" strike="noStrike" dirty="0">
+              <a:solidFill>
+                <a:srgbClr val="FFFFFF"/>
+              </a:solidFill>
+              <a:latin typeface="Calibri"/>
+              <a:cs typeface="Calibri"/>
+            </a:endParaRPr>
+          </a:p>
+        </p:txBody>
+      </p:sp>
+      <p:sp>
+        <p:nvSpPr>
+          <p:cNvPr id="9" name="TextBox 52"/>
+          <p:cNvSpPr txBox="1"/>
+          <p:nvPr/>
+        </p:nvSpPr>
+        <p:spPr>
+          <a:xfrm>
+            <a:off x="689560" y="4428586"/>
+            <a:ext cx="1468890" cy="4715414"/>
+          </a:xfrm>
+          <a:prstGeom prst="rect">
+            <a:avLst/>
+          </a:prstGeom>
+          <a:noFill/>
+          <a:ln>
+            <a:noFill/>
+          </a:ln>
+        </p:spPr>
+        <p:txBody>
+          <a:bodyPr wrap="square" lIns="0" tIns="0" rIns="0" bIns="0" anchor="t" rtlCol="0">
+            <a:spAutoFit/>
+          </a:bodyPr>
+          <a:lstStyle/>
+          <a:p>
+            <a:pPr algn="l" marL="0" indent="0">
+              <a:lnSpc>
+                <a:spcPct val="100000"/>
+              </a:lnSpc>
+              <a:spcBef>
+                <a:spcPts val="0"/>
+              </a:spcBef>
+              <a:spcAft>
+                <a:spcPts val="0"/>
+              </a:spcAft>
+              <a:buNone/>
+            </a:pPr>
+            <a:r>
+              <a:rPr lang="en-US" sz="1533" b="1" i="0" u="none" strike="noStrike" dirty="0">
+                <a:solidFill>
+                  <a:srgbClr val="132442"/>
+                </a:solidFill>
+                <a:latin typeface="Calibri"/>
+                <a:cs typeface="Calibri"/>
+              </a:rPr>
+              <a:t>Project</a:t>
+            </a:r>
+            <a:endParaRPr lang="en-US" sz="1533" b="1" i="0" u="none" strike="noStrike" dirty="0">
+              <a:solidFill>
+                <a:srgbClr val="132442"/>
+              </a:solidFill>
+              <a:latin typeface="Calibri"/>
+              <a:cs typeface="Calibri"/>
+            </a:endParaRPr>
+          </a:p>
+        </p:txBody>
+      </p:sp>
+      <p:sp>
+        <p:nvSpPr>
+          <p:cNvPr id="10" name="TextBox 53"/>
+          <p:cNvSpPr txBox="1"/>
+          <p:nvPr/>
+        </p:nvSpPr>
+        <p:spPr>
+          <a:xfrm>
+            <a:off x="2229240" y="4428586"/>
+            <a:ext cx="1468890" cy="4715414"/>
+          </a:xfrm>
+          <a:prstGeom prst="rect">
+            <a:avLst/>
+          </a:prstGeom>
+          <a:noFill/>
+          <a:ln>
+            <a:noFill/>
+          </a:ln>
+        </p:spPr>
+        <p:txBody>
+          <a:bodyPr wrap="square" lIns="0" tIns="0" rIns="0" bIns="0" anchor="t" rtlCol="0">
+            <a:spAutoFit/>
+          </a:bodyPr>
+          <a:lstStyle/>
+          <a:p>
+            <a:pPr algn="l" marL="0" indent="0">
+              <a:lnSpc>
+                <a:spcPct val="100000"/>
+              </a:lnSpc>
+              <a:spcBef>
+                <a:spcPts val="0"/>
+              </a:spcBef>
+              <a:spcAft>
+                <a:spcPts val="0"/>
+              </a:spcAft>
+              <a:buNone/>
+            </a:pPr>
+            <a:r>
+              <a:rPr lang="en-US" sz="1533" b="1" i="0" u="none" strike="noStrike" dirty="0">
+                <a:solidFill>
+                  <a:srgbClr val="132442"/>
+                </a:solidFill>
+                <a:latin typeface="Calibri"/>
+                <a:cs typeface="Calibri"/>
+              </a:rPr>
+              <a:t>Budget</a:t>
+            </a:r>
+            <a:endParaRPr lang="en-US" sz="1533" b="1" i="0" u="none" strike="noStrike" dirty="0">
+              <a:solidFill>
+                <a:srgbClr val="132442"/>
+              </a:solidFill>
+              <a:latin typeface="Calibri"/>
+              <a:cs typeface="Calibri"/>
+            </a:endParaRPr>
+          </a:p>
+        </p:txBody>
+      </p:sp>
+      <p:sp>
+        <p:nvSpPr>
+          <p:cNvPr id="11" name="TextBox 54"/>
+          <p:cNvSpPr txBox="1"/>
+          <p:nvPr/>
+        </p:nvSpPr>
+        <p:spPr>
+          <a:xfrm>
+            <a:off x="3768920" y="4428586"/>
+            <a:ext cx="1468890" cy="4715414"/>
+          </a:xfrm>
+          <a:prstGeom prst="rect">
+            <a:avLst/>
+          </a:prstGeom>
+          <a:noFill/>
+          <a:ln>
+            <a:noFill/>
+          </a:ln>
+        </p:spPr>
+        <p:txBody>
+          <a:bodyPr wrap="square" lIns="0" tIns="0" rIns="0" bIns="0" anchor="t" rtlCol="0">
+            <a:spAutoFit/>
+          </a:bodyPr>
+          <a:lstStyle/>
+          <a:p>
+            <a:pPr algn="l" marL="0" indent="0">
+              <a:lnSpc>
+                <a:spcPct val="100000"/>
+              </a:lnSpc>
+              <a:spcBef>
+                <a:spcPts val="0"/>
+              </a:spcBef>
+              <a:spcAft>
+                <a:spcPts val="0"/>
+              </a:spcAft>
+              <a:buNone/>
+            </a:pPr>
+            <a:r>
+              <a:rPr lang="en-US" sz="1533" b="1" i="0" u="none" strike="noStrike" dirty="0">
+                <a:solidFill>
+                  <a:srgbClr val="132442"/>
+                </a:solidFill>
+                <a:latin typeface="Calibri"/>
+                <a:cs typeface="Calibri"/>
+              </a:rPr>
+              <a:t>Actual</a:t>
+            </a:r>
+            <a:endParaRPr lang="en-US" sz="1533" b="1" i="0" u="none" strike="noStrike" dirty="0">
+              <a:solidFill>
+                <a:srgbClr val="132442"/>
+              </a:solidFill>
+              <a:latin typeface="Calibri"/>
+              <a:cs typeface="Calibri"/>
+            </a:endParaRPr>
+          </a:p>
+        </p:txBody>
+      </p:sp>
+      <p:sp>
+        <p:nvSpPr>
+          <p:cNvPr id="12" name="Rectangle 55"/>
+          <p:cNvSpPr/>
+          <p:nvPr/>
+        </p:nvSpPr>
+        <p:spPr>
+          <a:xfrm>
+            <a:off x="547980" y="4791384"/>
+            <a:ext cx="4619040" cy="424739"/>
+          </a:xfrm>
+          <a:prstGeom prst="rect">
+            <a:avLst/>
+          </a:prstGeom>
+          <a:solidFill>
+            <a:srgbClr val="F6FAF7"/>
+          </a:solidFill>
+          <a:ln>
+            <a:noFill/>
+          </a:ln>
+        </p:spPr>
+        <p:txBody>
+          <a:bodyPr wrap="square" lIns="91440" tIns="45720" rIns="91440" bIns="45720" anchor="ctr" rtlCol="0">
+            <a:noAutofit/>
+          </a:bodyPr>
+          <a:lstStyle/>
+          <a:p>
+            <a:pPr algn="ctr" marL="0" indent="0">
+              <a:lnSpc>
+                <a:spcPct val="100000"/>
+              </a:lnSpc>
+              <a:spcBef>
+                <a:spcPts val="0"/>
+              </a:spcBef>
+              <a:spcAft>
+                <a:spcPts val="0"/>
+              </a:spcAft>
+              <a:buNone/>
+            </a:pPr>
+            <a:endParaRPr lang="en-US" sz="1800" b="0" i="0" u="none" strike="noStrike" dirty="0">
+              <a:solidFill>
+                <a:srgbClr val="FFFFFF"/>
+              </a:solidFill>
+              <a:latin typeface="Calibri"/>
+              <a:cs typeface="Calibri"/>
+            </a:endParaRPr>
+          </a:p>
+        </p:txBody>
+      </p:sp>
+      <p:sp>
+        <p:nvSpPr>
+          <p:cNvPr id="13" name="TextBox 56"/>
+          <p:cNvSpPr txBox="1"/>
+          <p:nvPr/>
+        </p:nvSpPr>
+        <p:spPr>
+          <a:xfrm>
+            <a:off x="689560" y="4862174"/>
+            <a:ext cx="1468890" cy="4281826"/>
+          </a:xfrm>
+          <a:prstGeom prst="rect">
+            <a:avLst/>
+          </a:prstGeom>
+          <a:noFill/>
+          <a:ln>
+            <a:noFill/>
+          </a:ln>
+        </p:spPr>
+        <p:txBody>
+          <a:bodyPr wrap="square" lIns="0" tIns="0" rIns="0" bIns="0" anchor="t" rtlCol="0">
+            <a:spAutoFit/>
+          </a:bodyPr>
+          <a:lstStyle/>
+          <a:p>
+            <a:pPr algn="l" marL="0" indent="0">
+              <a:lnSpc>
+                <a:spcPct val="100000"/>
+              </a:lnSpc>
+              <a:spcBef>
+                <a:spcPts val="0"/>
+              </a:spcBef>
+              <a:spcAft>
+                <a:spcPts val="0"/>
+              </a:spcAft>
+              <a:buNone/>
+            </a:pPr>
+            <a:r>
+              <a:rPr lang="en-US" sz="1533" b="0" i="0" u="none" strike="noStrike" dirty="0">
+                <a:solidFill>
+                  <a:srgbClr val="132442"/>
+                </a:solidFill>
+                <a:latin typeface="Calibri"/>
+                <a:cs typeface="Calibri"/>
+              </a:rPr>
+              <a:t>Design</a:t>
+            </a:r>
+            <a:endParaRPr lang="en-US" sz="1533" b="0" i="0" u="none" strike="noStrike" dirty="0">
+              <a:solidFill>
+                <a:srgbClr val="132442"/>
+              </a:solidFill>
+              <a:latin typeface="Calibri"/>
+              <a:cs typeface="Calibri"/>
+            </a:endParaRPr>
+          </a:p>
+        </p:txBody>
+      </p:sp>
+      <p:sp>
+        <p:nvSpPr>
+          <p:cNvPr id="14" name="TextBox 57"/>
+          <p:cNvSpPr txBox="1"/>
+          <p:nvPr/>
+        </p:nvSpPr>
+        <p:spPr>
+          <a:xfrm>
+            <a:off x="2229240" y="4862174"/>
+            <a:ext cx="1468890" cy="4281826"/>
+          </a:xfrm>
+          <a:prstGeom prst="rect">
+            <a:avLst/>
+          </a:prstGeom>
+          <a:noFill/>
+          <a:ln>
+            <a:noFill/>
+          </a:ln>
+        </p:spPr>
+        <p:txBody>
+          <a:bodyPr wrap="square" lIns="0" tIns="0" rIns="0" bIns="0" anchor="t" rtlCol="0">
+            <a:spAutoFit/>
+          </a:bodyPr>
+          <a:lstStyle/>
+          <a:p>
+            <a:pPr algn="l" marL="0" indent="0">
+              <a:lnSpc>
+                <a:spcPct val="100000"/>
+              </a:lnSpc>
+              <a:spcBef>
+                <a:spcPts val="0"/>
+              </a:spcBef>
+              <a:spcAft>
+                <a:spcPts val="0"/>
+              </a:spcAft>
+              <a:buNone/>
+            </a:pPr>
+            <a:r>
+              <a:rPr lang="en-US" sz="1533" b="0" i="0" u="none" strike="noStrike" dirty="0">
+                <a:solidFill>
+                  <a:srgbClr val="132442"/>
+                </a:solidFill>
+                <a:latin typeface="Calibri"/>
+                <a:cs typeface="Calibri"/>
+              </a:rPr>
+              <a:t>2,400</a:t>
+            </a:r>
+            <a:endParaRPr lang="en-US" sz="1533" b="0" i="0" u="none" strike="noStrike" dirty="0">
+              <a:solidFill>
+                <a:srgbClr val="132442"/>
+              </a:solidFill>
+              <a:latin typeface="Calibri"/>
+              <a:cs typeface="Calibri"/>
+            </a:endParaRPr>
+          </a:p>
+        </p:txBody>
+      </p:sp>
+      <p:sp>
+        <p:nvSpPr>
+          <p:cNvPr id="15" name="TextBox 58"/>
+          <p:cNvSpPr txBox="1"/>
+          <p:nvPr/>
+        </p:nvSpPr>
+        <p:spPr>
+          <a:xfrm>
+            <a:off x="3768920" y="4862174"/>
+            <a:ext cx="1468890" cy="4281826"/>
+          </a:xfrm>
+          <a:prstGeom prst="rect">
+            <a:avLst/>
+          </a:prstGeom>
+          <a:noFill/>
+          <a:ln>
+            <a:noFill/>
+          </a:ln>
+        </p:spPr>
+        <p:txBody>
+          <a:bodyPr wrap="square" lIns="0" tIns="0" rIns="0" bIns="0" anchor="t" rtlCol="0">
+            <a:spAutoFit/>
+          </a:bodyPr>
+          <a:lstStyle/>
+          <a:p>
+            <a:pPr algn="l" marL="0" indent="0">
+              <a:lnSpc>
+                <a:spcPct val="100000"/>
+              </a:lnSpc>
+              <a:spcBef>
+                <a:spcPts val="0"/>
+              </a:spcBef>
+              <a:spcAft>
+                <a:spcPts val="0"/>
+              </a:spcAft>
+              <a:buNone/>
+            </a:pPr>
+            <a:r>
+              <a:rPr lang="en-US" sz="1533" b="0" i="0" u="none" strike="noStrike" dirty="0">
+                <a:solidFill>
+                  <a:srgbClr val="132442"/>
+                </a:solidFill>
+                <a:latin typeface="Calibri"/>
+                <a:cs typeface="Calibri"/>
+              </a:rPr>
+              <a:t>2,100</a:t>
+            </a:r>
+            <a:endParaRPr lang="en-US" sz="1533" b="0" i="0" u="none" strike="noStrike" dirty="0">
+              <a:solidFill>
+                <a:srgbClr val="132442"/>
+              </a:solidFill>
+              <a:latin typeface="Calibri"/>
+              <a:cs typeface="Calibri"/>
+            </a:endParaRPr>
+          </a:p>
+        </p:txBody>
+      </p:sp>
+      <p:sp>
+        <p:nvSpPr>
+          <p:cNvPr id="16" name="Rectangle 59"/>
+          <p:cNvSpPr/>
+          <p:nvPr/>
+        </p:nvSpPr>
+        <p:spPr>
+          <a:xfrm>
+            <a:off x="547980" y="5224973"/>
+            <a:ext cx="4619040" cy="424739"/>
+          </a:xfrm>
+          <a:prstGeom prst="rect">
+            <a:avLst/>
+          </a:prstGeom>
+          <a:solidFill>
+            <a:srgbClr val="F6FAF7"/>
+          </a:solidFill>
+          <a:ln>
+            <a:noFill/>
+          </a:ln>
+        </p:spPr>
+        <p:txBody>
+          <a:bodyPr wrap="square" lIns="91440" tIns="45720" rIns="91440" bIns="45720" anchor="ctr" rtlCol="0">
+            <a:noAutofit/>
+          </a:bodyPr>
+          <a:lstStyle/>
+          <a:p>
+            <a:pPr algn="ctr" marL="0" indent="0">
+              <a:lnSpc>
+                <a:spcPct val="100000"/>
+              </a:lnSpc>
+              <a:spcBef>
+                <a:spcPts val="0"/>
+              </a:spcBef>
+              <a:spcAft>
+                <a:spcPts val="0"/>
+              </a:spcAft>
+              <a:buNone/>
+            </a:pPr>
+            <a:endParaRPr lang="en-US" sz="1800" b="0" i="0" u="none" strike="noStrike" dirty="0">
+              <a:solidFill>
+                <a:srgbClr val="FFFFFF"/>
+              </a:solidFill>
+              <a:latin typeface="Calibri"/>
+              <a:cs typeface="Calibri"/>
+            </a:endParaRPr>
+          </a:p>
+        </p:txBody>
+      </p:sp>
+      <p:sp>
+        <p:nvSpPr>
+          <p:cNvPr id="17" name="TextBox 60"/>
+          <p:cNvSpPr txBox="1"/>
+          <p:nvPr/>
+        </p:nvSpPr>
+        <p:spPr>
+          <a:xfrm>
+            <a:off x="689560" y="5295762"/>
+            <a:ext cx="1468890" cy="3848238"/>
+          </a:xfrm>
+          <a:prstGeom prst="rect">
+            <a:avLst/>
+          </a:prstGeom>
+          <a:noFill/>
+          <a:ln>
+            <a:noFill/>
+          </a:ln>
+        </p:spPr>
+        <p:txBody>
+          <a:bodyPr wrap="square" lIns="0" tIns="0" rIns="0" bIns="0" anchor="t" rtlCol="0">
+            <a:spAutoFit/>
+          </a:bodyPr>
+          <a:lstStyle/>
+          <a:p>
+            <a:pPr algn="l" marL="0" indent="0">
+              <a:lnSpc>
+                <a:spcPct val="100000"/>
+              </a:lnSpc>
+              <a:spcBef>
+                <a:spcPts val="0"/>
+              </a:spcBef>
+              <a:spcAft>
+                <a:spcPts val="0"/>
+              </a:spcAft>
+              <a:buNone/>
+            </a:pPr>
+            <a:r>
+              <a:rPr lang="en-US" sz="1533" b="0" i="0" u="none" strike="noStrike" dirty="0">
+                <a:solidFill>
+                  <a:srgbClr val="132442"/>
+                </a:solidFill>
+                <a:latin typeface="Calibri"/>
+                <a:cs typeface="Calibri"/>
+              </a:rPr>
+              <a:t>Build</a:t>
+            </a:r>
+            <a:endParaRPr lang="en-US" sz="1533" b="0" i="0" u="none" strike="noStrike" dirty="0">
+              <a:solidFill>
+                <a:srgbClr val="132442"/>
+              </a:solidFill>
+              <a:latin typeface="Calibri"/>
+              <a:cs typeface="Calibri"/>
+            </a:endParaRPr>
+          </a:p>
+        </p:txBody>
+      </p:sp>
+      <p:sp>
+        <p:nvSpPr>
+          <p:cNvPr id="18" name="TextBox 61"/>
+          <p:cNvSpPr txBox="1"/>
+          <p:nvPr/>
+        </p:nvSpPr>
+        <p:spPr>
+          <a:xfrm>
+            <a:off x="2229240" y="5295762"/>
+            <a:ext cx="1468890" cy="3848238"/>
+          </a:xfrm>
+          <a:prstGeom prst="rect">
+            <a:avLst/>
+          </a:prstGeom>
+          <a:noFill/>
+          <a:ln>
+            <a:noFill/>
+          </a:ln>
+        </p:spPr>
+        <p:txBody>
+          <a:bodyPr wrap="square" lIns="0" tIns="0" rIns="0" bIns="0" anchor="t" rtlCol="0">
+            <a:spAutoFit/>
+          </a:bodyPr>
+          <a:lstStyle/>
+          <a:p>
+            <a:pPr algn="l" marL="0" indent="0">
+              <a:lnSpc>
+                <a:spcPct val="100000"/>
+              </a:lnSpc>
+              <a:spcBef>
+                <a:spcPts val="0"/>
+              </a:spcBef>
+              <a:spcAft>
+                <a:spcPts val="0"/>
+              </a:spcAft>
+              <a:buNone/>
+            </a:pPr>
+            <a:r>
+              <a:rPr lang="en-US" sz="1533" b="0" i="0" u="none" strike="noStrike" dirty="0">
+                <a:solidFill>
+                  <a:srgbClr val="132442"/>
+                </a:solidFill>
+                <a:latin typeface="Calibri"/>
+                <a:cs typeface="Calibri"/>
+              </a:rPr>
+              <a:t>6,800</a:t>
+            </a:r>
+            <a:endParaRPr lang="en-US" sz="1533" b="0" i="0" u="none" strike="noStrike" dirty="0">
+              <a:solidFill>
+                <a:srgbClr val="132442"/>
+              </a:solidFill>
+              <a:latin typeface="Calibri"/>
+              <a:cs typeface="Calibri"/>
+            </a:endParaRPr>
+          </a:p>
+        </p:txBody>
+      </p:sp>
+      <p:sp>
+        <p:nvSpPr>
+          <p:cNvPr id="19" name="TextBox 62"/>
+          <p:cNvSpPr txBox="1"/>
+          <p:nvPr/>
+        </p:nvSpPr>
+        <p:spPr>
+          <a:xfrm>
+            <a:off x="3768920" y="5295762"/>
+            <a:ext cx="1468890" cy="3848238"/>
+          </a:xfrm>
+          <a:prstGeom prst="rect">
+            <a:avLst/>
+          </a:prstGeom>
+          <a:noFill/>
+          <a:ln>
+            <a:noFill/>
+          </a:ln>
+        </p:spPr>
+        <p:txBody>
+          <a:bodyPr wrap="square" lIns="0" tIns="0" rIns="0" bIns="0" anchor="t" rtlCol="0">
+            <a:spAutoFit/>
+          </a:bodyPr>
+          <a:lstStyle/>
+          <a:p>
+            <a:pPr algn="l" marL="0" indent="0">
+              <a:lnSpc>
+                <a:spcPct val="100000"/>
+              </a:lnSpc>
+              <a:spcBef>
+                <a:spcPts val="0"/>
+              </a:spcBef>
+              <a:spcAft>
+                <a:spcPts val="0"/>
+              </a:spcAft>
+              <a:buNone/>
+            </a:pPr>
+            <a:r>
+              <a:rPr lang="en-US" sz="1533" b="0" i="0" u="none" strike="noStrike" dirty="0">
+                <a:solidFill>
+                  <a:srgbClr val="132442"/>
+                </a:solidFill>
+                <a:latin typeface="Calibri"/>
+                <a:cs typeface="Calibri"/>
+              </a:rPr>
+              <a:t>6,500</a:t>
+            </a:r>
+            <a:endParaRPr lang="en-US" sz="1533" b="0" i="0" u="none" strike="noStrike" dirty="0">
+              <a:solidFill>
+                <a:srgbClr val="132442"/>
+              </a:solidFill>
+              <a:latin typeface="Calibri"/>
+              <a:cs typeface="Calibri"/>
+            </a:endParaRPr>
+          </a:p>
+        </p:txBody>
+      </p:sp>
+      <p:sp>
+        <p:nvSpPr>
+          <p:cNvPr id="20" name="Rectangle 63"/>
+          <p:cNvSpPr/>
+          <p:nvPr/>
+        </p:nvSpPr>
+        <p:spPr>
+          <a:xfrm>
+            <a:off x="547980" y="5658561"/>
+            <a:ext cx="4619040" cy="424739"/>
+          </a:xfrm>
+          <a:prstGeom prst="rect">
+            <a:avLst/>
+          </a:prstGeom>
+          <a:solidFill>
+            <a:srgbClr val="F6FAF7"/>
+          </a:solidFill>
+          <a:ln>
+            <a:noFill/>
+          </a:ln>
+        </p:spPr>
+        <p:txBody>
+          <a:bodyPr wrap="square" lIns="91440" tIns="45720" rIns="91440" bIns="45720" anchor="ctr" rtlCol="0">
+            <a:noAutofit/>
+          </a:bodyPr>
+          <a:lstStyle/>
+          <a:p>
+            <a:pPr algn="ctr" marL="0" indent="0">
+              <a:lnSpc>
+                <a:spcPct val="100000"/>
+              </a:lnSpc>
+              <a:spcBef>
+                <a:spcPts val="0"/>
+              </a:spcBef>
+              <a:spcAft>
+                <a:spcPts val="0"/>
+              </a:spcAft>
+              <a:buNone/>
+            </a:pPr>
+            <a:endParaRPr lang="en-US" sz="1800" b="0" i="0" u="none" strike="noStrike" dirty="0">
+              <a:solidFill>
+                <a:srgbClr val="FFFFFF"/>
+              </a:solidFill>
+              <a:latin typeface="Calibri"/>
+              <a:cs typeface="Calibri"/>
+            </a:endParaRPr>
+          </a:p>
+        </p:txBody>
+      </p:sp>
+      <p:sp>
+        <p:nvSpPr>
+          <p:cNvPr id="21" name="TextBox 64"/>
+          <p:cNvSpPr txBox="1"/>
+          <p:nvPr/>
+        </p:nvSpPr>
+        <p:spPr>
+          <a:xfrm>
+            <a:off x="689560" y="5729351"/>
+            <a:ext cx="1468890" cy="3414649"/>
+          </a:xfrm>
+          <a:prstGeom prst="rect">
+            <a:avLst/>
+          </a:prstGeom>
+          <a:noFill/>
+          <a:ln>
+            <a:noFill/>
+          </a:ln>
+        </p:spPr>
+        <p:txBody>
+          <a:bodyPr wrap="square" lIns="0" tIns="0" rIns="0" bIns="0" anchor="t" rtlCol="0">
+            <a:spAutoFit/>
+          </a:bodyPr>
+          <a:lstStyle/>
+          <a:p>
+            <a:pPr algn="l" marL="0" indent="0">
+              <a:lnSpc>
+                <a:spcPct val="100000"/>
+              </a:lnSpc>
+              <a:spcBef>
+                <a:spcPts val="0"/>
+              </a:spcBef>
+              <a:spcAft>
+                <a:spcPts val="0"/>
+              </a:spcAft>
+              <a:buNone/>
+            </a:pPr>
+            <a:r>
+              <a:rPr lang="en-US" sz="1533" b="0" i="0" u="none" strike="noStrike" dirty="0">
+                <a:solidFill>
+                  <a:srgbClr val="132442"/>
+                </a:solidFill>
+                <a:latin typeface="Calibri"/>
+                <a:cs typeface="Calibri"/>
+              </a:rPr>
+              <a:t>Launch</a:t>
+            </a:r>
+            <a:endParaRPr lang="en-US" sz="1533" b="0" i="0" u="none" strike="noStrike" dirty="0">
+              <a:solidFill>
+                <a:srgbClr val="132442"/>
+              </a:solidFill>
+              <a:latin typeface="Calibri"/>
+              <a:cs typeface="Calibri"/>
+            </a:endParaRPr>
+          </a:p>
+        </p:txBody>
+      </p:sp>
+      <p:sp>
+        <p:nvSpPr>
+          <p:cNvPr id="22" name="TextBox 65"/>
+          <p:cNvSpPr txBox="1"/>
+          <p:nvPr/>
+        </p:nvSpPr>
+        <p:spPr>
+          <a:xfrm>
+            <a:off x="2229240" y="5729351"/>
+            <a:ext cx="1468890" cy="3414649"/>
+          </a:xfrm>
+          <a:prstGeom prst="rect">
+            <a:avLst/>
+          </a:prstGeom>
+          <a:noFill/>
+          <a:ln>
+            <a:noFill/>
+          </a:ln>
+        </p:spPr>
+        <p:txBody>
+          <a:bodyPr wrap="square" lIns="0" tIns="0" rIns="0" bIns="0" anchor="t" rtlCol="0">
+            <a:spAutoFit/>
+          </a:bodyPr>
+          <a:lstStyle/>
+          <a:p>
+            <a:pPr algn="l" marL="0" indent="0">
+              <a:lnSpc>
+                <a:spcPct val="100000"/>
+              </a:lnSpc>
+              <a:spcBef>
+                <a:spcPts val="0"/>
+              </a:spcBef>
+              <a:spcAft>
+                <a:spcPts val="0"/>
+              </a:spcAft>
+              <a:buNone/>
+            </a:pPr>
+            <a:r>
+              <a:rPr lang="en-US" sz="1533" b="0" i="0" u="none" strike="noStrike" dirty="0">
+                <a:solidFill>
+                  <a:srgbClr val="132442"/>
+                </a:solidFill>
+                <a:latin typeface="Calibri"/>
+                <a:cs typeface="Calibri"/>
+              </a:rPr>
+              <a:t>1,800</a:t>
+            </a:r>
+            <a:endParaRPr lang="en-US" sz="1533" b="0" i="0" u="none" strike="noStrike" dirty="0">
+              <a:solidFill>
+                <a:srgbClr val="132442"/>
+              </a:solidFill>
+              <a:latin typeface="Calibri"/>
+              <a:cs typeface="Calibri"/>
+            </a:endParaRPr>
+          </a:p>
+        </p:txBody>
+      </p:sp>
+      <p:sp>
+        <p:nvSpPr>
+          <p:cNvPr id="23" name="TextBox 66"/>
+          <p:cNvSpPr txBox="1"/>
+          <p:nvPr/>
+        </p:nvSpPr>
+        <p:spPr>
+          <a:xfrm>
+            <a:off x="3768920" y="5729351"/>
+            <a:ext cx="1468890" cy="3414649"/>
+          </a:xfrm>
+          <a:prstGeom prst="rect">
+            <a:avLst/>
+          </a:prstGeom>
+          <a:noFill/>
+          <a:ln>
+            <a:noFill/>
+          </a:ln>
+        </p:spPr>
+        <p:txBody>
+          <a:bodyPr wrap="square" lIns="0" tIns="0" rIns="0" bIns="0" anchor="t" rtlCol="0">
+            <a:spAutoFit/>
+          </a:bodyPr>
+          <a:lstStyle/>
+          <a:p>
+            <a:pPr algn="l" marL="0" indent="0">
+              <a:lnSpc>
+                <a:spcPct val="100000"/>
+              </a:lnSpc>
+              <a:spcBef>
+                <a:spcPts val="0"/>
+              </a:spcBef>
+              <a:spcAft>
+                <a:spcPts val="0"/>
+              </a:spcAft>
+              <a:buNone/>
+            </a:pPr>
+            <a:r>
+              <a:rPr lang="en-US" sz="1533" b="0" i="0" u="none" strike="noStrike" dirty="0">
+                <a:solidFill>
+                  <a:srgbClr val="132442"/>
+                </a:solidFill>
+                <a:latin typeface="Calibri"/>
+                <a:cs typeface="Calibri"/>
+              </a:rPr>
+              <a:t>1,400</a:t>
+            </a:r>
+            <a:endParaRPr lang="en-US" sz="1533" b="0" i="0" u="none" strike="noStrike" dirty="0">
+              <a:solidFill>
+                <a:srgbClr val="132442"/>
+              </a:solidFill>
+              <a:latin typeface="Calibri"/>
+              <a:cs typeface="Calibri"/>
+            </a:endParaRPr>
+          </a:p>
+        </p:txBody>
+      </p:sp>
+      <p:sp>
+        <p:nvSpPr>
+          <p:cNvPr id="24" name="Rectangle 67"/>
+          <p:cNvSpPr/>
+          <p:nvPr/>
+        </p:nvSpPr>
+        <p:spPr>
+          <a:xfrm>
+            <a:off x="547980" y="6092149"/>
+            <a:ext cx="4619040" cy="424739"/>
+          </a:xfrm>
+          <a:prstGeom prst="rect">
+            <a:avLst/>
+          </a:prstGeom>
+          <a:solidFill>
+            <a:srgbClr val="13794D"/>
+          </a:solidFill>
+          <a:ln>
+            <a:noFill/>
+          </a:ln>
+        </p:spPr>
+        <p:txBody>
+          <a:bodyPr wrap="square" lIns="91440" tIns="45720" rIns="91440" bIns="45720" anchor="ctr" rtlCol="0">
+            <a:noAutofit/>
+          </a:bodyPr>
+          <a:lstStyle/>
+          <a:p>
+            <a:pPr algn="ctr" marL="0" indent="0">
+              <a:lnSpc>
+                <a:spcPct val="100000"/>
+              </a:lnSpc>
+              <a:spcBef>
+                <a:spcPts val="0"/>
+              </a:spcBef>
+              <a:spcAft>
+                <a:spcPts val="0"/>
+              </a:spcAft>
+              <a:buNone/>
+            </a:pPr>
+            <a:endParaRPr lang="en-US" sz="1800" b="0" i="0" u="none" strike="noStrike" dirty="0">
+              <a:solidFill>
+                <a:srgbClr val="FFFFFF"/>
+              </a:solidFill>
+              <a:latin typeface="Calibri"/>
+              <a:cs typeface="Calibri"/>
+            </a:endParaRPr>
+          </a:p>
+        </p:txBody>
+      </p:sp>
+      <p:sp>
+        <p:nvSpPr>
+          <p:cNvPr id="25" name="TextBox 68"/>
+          <p:cNvSpPr txBox="1"/>
+          <p:nvPr/>
+        </p:nvSpPr>
+        <p:spPr>
+          <a:xfrm>
+            <a:off x="689560" y="6162939"/>
+            <a:ext cx="1468890" cy="2981061"/>
+          </a:xfrm>
+          <a:prstGeom prst="rect">
+            <a:avLst/>
+          </a:prstGeom>
+          <a:noFill/>
+          <a:ln>
+            <a:noFill/>
+          </a:ln>
+        </p:spPr>
+        <p:txBody>
+          <a:bodyPr wrap="square" lIns="0" tIns="0" rIns="0" bIns="0" anchor="t" rtlCol="0">
+            <a:spAutoFit/>
+          </a:bodyPr>
+          <a:lstStyle/>
+          <a:p>
+            <a:pPr algn="l" marL="0" indent="0">
+              <a:lnSpc>
+                <a:spcPct val="100000"/>
+              </a:lnSpc>
+              <a:spcBef>
+                <a:spcPts val="0"/>
+              </a:spcBef>
+              <a:spcAft>
+                <a:spcPts val="0"/>
+              </a:spcAft>
+              <a:buNone/>
+            </a:pPr>
+            <a:r>
+              <a:rPr lang="en-US" sz="1533" b="1" i="0" u="none" strike="noStrike" dirty="0">
+                <a:solidFill>
+                  <a:srgbClr val="FFFFFF"/>
+                </a:solidFill>
+                <a:latin typeface="Calibri"/>
+                <a:cs typeface="Calibri"/>
+              </a:rPr>
+              <a:t>Total</a:t>
+            </a:r>
+            <a:endParaRPr lang="en-US" sz="1533" b="1" i="0" u="none" strike="noStrike" dirty="0">
+              <a:solidFill>
+                <a:srgbClr val="FFFFFF"/>
+              </a:solidFill>
+              <a:latin typeface="Calibri"/>
+              <a:cs typeface="Calibri"/>
+            </a:endParaRPr>
+          </a:p>
+        </p:txBody>
+      </p:sp>
+      <p:sp>
+        <p:nvSpPr>
+          <p:cNvPr id="26" name="TextBox 69"/>
+          <p:cNvSpPr txBox="1"/>
+          <p:nvPr/>
+        </p:nvSpPr>
+        <p:spPr>
+          <a:xfrm>
+            <a:off x="2229240" y="6162939"/>
+            <a:ext cx="1468890" cy="2981061"/>
+          </a:xfrm>
+          <a:prstGeom prst="rect">
+            <a:avLst/>
+          </a:prstGeom>
+          <a:noFill/>
+          <a:ln>
+            <a:noFill/>
+          </a:ln>
+        </p:spPr>
+        <p:txBody>
+          <a:bodyPr wrap="square" lIns="0" tIns="0" rIns="0" bIns="0" anchor="t" rtlCol="0">
+            <a:spAutoFit/>
+          </a:bodyPr>
+          <a:lstStyle/>
+          <a:p>
+            <a:pPr algn="l" marL="0" indent="0">
+              <a:lnSpc>
+                <a:spcPct val="100000"/>
+              </a:lnSpc>
+              <a:spcBef>
+                <a:spcPts val="0"/>
+              </a:spcBef>
+              <a:spcAft>
+                <a:spcPts val="0"/>
+              </a:spcAft>
+              <a:buNone/>
+            </a:pPr>
+            <a:r>
+              <a:rPr lang="en-US" sz="1533" b="1" i="0" u="none" strike="noStrike" dirty="0">
+                <a:solidFill>
+                  <a:srgbClr val="FFFFFF"/>
+                </a:solidFill>
+                <a:latin typeface="Calibri"/>
+                <a:cs typeface="Calibri"/>
+              </a:rPr>
+              <a:t>11,000</a:t>
+            </a:r>
+            <a:endParaRPr lang="en-US" sz="1533" b="1" i="0" u="none" strike="noStrike" dirty="0">
+              <a:solidFill>
+                <a:srgbClr val="FFFFFF"/>
+              </a:solidFill>
+              <a:latin typeface="Calibri"/>
+              <a:cs typeface="Calibri"/>
+            </a:endParaRPr>
+          </a:p>
+        </p:txBody>
+      </p:sp>
+      <p:sp>
+        <p:nvSpPr>
+          <p:cNvPr id="27" name="TextBox 70"/>
+          <p:cNvSpPr txBox="1"/>
+          <p:nvPr/>
+        </p:nvSpPr>
+        <p:spPr>
+          <a:xfrm>
+            <a:off x="3768920" y="6162939"/>
+            <a:ext cx="1468890" cy="2981061"/>
+          </a:xfrm>
+          <a:prstGeom prst="rect">
+            <a:avLst/>
+          </a:prstGeom>
+          <a:noFill/>
+          <a:ln>
+            <a:noFill/>
+          </a:ln>
+        </p:spPr>
+        <p:txBody>
+          <a:bodyPr wrap="square" lIns="0" tIns="0" rIns="0" bIns="0" anchor="t" rtlCol="0">
+            <a:spAutoFit/>
+          </a:bodyPr>
+          <a:lstStyle/>
+          <a:p>
+            <a:pPr algn="l" marL="0" indent="0">
+              <a:lnSpc>
+                <a:spcPct val="100000"/>
+              </a:lnSpc>
+              <a:spcBef>
+                <a:spcPts val="0"/>
+              </a:spcBef>
+              <a:spcAft>
+                <a:spcPts val="0"/>
+              </a:spcAft>
+              <a:buNone/>
+            </a:pPr>
+            <a:r>
+              <a:rPr lang="en-US" sz="1533" b="1" i="0" u="none" strike="noStrike" dirty="0">
+                <a:solidFill>
+                  <a:srgbClr val="FFFFFF"/>
+                </a:solidFill>
+                <a:latin typeface="Calibri"/>
+                <a:cs typeface="Calibri"/>
+              </a:rPr>
+              <a:t>10,000</a:t>
+            </a:r>
+            <a:endParaRPr lang="en-US" sz="1533" b="1" i="0" u="none" strike="noStrike" dirty="0">
+              <a:solidFill>
+                <a:srgbClr val="FFFFFF"/>
+              </a:solidFill>
+              <a:latin typeface="Calibri"/>
+              <a:cs typeface="Calibri"/>
+            </a:endParaRPr>
+          </a:p>
+        </p:txBody>
+      </p:sp>
+      <p:sp>
+        <p:nvSpPr>
+          <p:cNvPr id="28" name="TextBox 71"/>
+          <p:cNvSpPr txBox="1"/>
+          <p:nvPr/>
+        </p:nvSpPr>
+        <p:spPr>
+          <a:xfrm>
+            <a:off x="406400" y="8305800"/>
+            <a:ext cx="4902200" cy="838200"/>
+          </a:xfrm>
+          <a:prstGeom prst="rect">
+            <a:avLst/>
+          </a:prstGeom>
+          <a:noFill/>
+          <a:ln>
+            <a:noFill/>
+          </a:ln>
+        </p:spPr>
+        <p:txBody>
+          <a:bodyPr wrap="square" lIns="0" tIns="0" rIns="0" bIns="0" anchor="t" rtlCol="0">
+            <a:spAutoFit/>
+          </a:bodyPr>
+          <a:lstStyle/>
+          <a:p>
+            <a:pPr algn="l" marL="0" indent="0">
+              <a:lnSpc>
+                <a:spcPct val="100000"/>
+              </a:lnSpc>
+              <a:spcBef>
+                <a:spcPts val="0"/>
+              </a:spcBef>
+              <a:spcAft>
+                <a:spcPts val="0"/>
+              </a:spcAft>
+              <a:buNone/>
+            </a:pPr>
+            <a:r>
+              <a:rPr lang="en-US" sz="1300" b="1" i="0" u="none" strike="noStrike" dirty="0">
+                <a:solidFill>
+                  <a:srgbClr val="13794D"/>
+                </a:solidFill>
+                <a:latin typeface="Calibri"/>
+                <a:cs typeface="Calibri"/>
+              </a:rPr>
+              <a:t>XLSX  ·  CSV  ·  FORMULAS  ·  FILTERS</a:t>
+            </a:r>
+            <a:endParaRPr lang="en-US" sz="1300" b="1" i="0" u="none" strike="noStrike" dirty="0">
+              <a:solidFill>
+                <a:srgbClr val="13794D"/>
+              </a:solidFill>
+              <a:latin typeface="Calibri"/>
+              <a:cs typeface="Calibri"/>
+            </a:endParaRPr>
+          </a:p>
+        </p:txBody>
+      </p:sp>
+    </p:spTree>
+  </p:cSld>
+  <p:clrMapOvr>
+    <a:masterClrMapping/>
+  </p:clrMapOvr>
+  <p:transition spd="fast">
+    <p:fade/>
+  </p:transition>
+</p:sld>
+</file>
+
+<file path=ppt/slides/slide5.xml><?xml version="1.0" encoding="utf-8"?>
 <p:sld xmlns:a="http://schemas.openxmlformats.org/drawingml/2006/main" xmlns:r="http://schemas.openxmlformats.org/officeDocument/2006/relationships" xmlns:p="http://schemas.openxmlformats.org/presentationml/2006/main">
   <p:cSld>
     <p:bg>
@@ -3376,7 +6085,7 @@
       </p:grpSpPr>
       <p:sp>
         <p:nvSpPr>
-          <p:cNvPr id="2" name="TextBox 25"/>
+          <p:cNvPr id="2" name="TextBox 73"/>
           <p:cNvSpPr txBox="1"/>
           <p:nvPr/>
         </p:nvSpPr>
@@ -3419,7 +6128,7 @@
                 <a:latin typeface="Calibri"/>
                 <a:cs typeface="Calibri"/>
               </a:rPr>
-              <a:t>02  /  SIX PLATFORMS. ONE AMBITION.</a:t>
+              <a:t>04  /  SIX PLATFORMS. ONE AMBITION.</a:t>
             </a:r>
             <a:endParaRPr lang="en-US" sz="1300" b="1" i="0" u="none" strike="noStrike" dirty="0">
               <a:solidFill>
@@ -3433,7 +6142,7 @@
       </p:sp>
       <p:sp>
         <p:nvSpPr>
-          <p:cNvPr id="3" name="TextBox 26"/>
+          <p:cNvPr id="3" name="TextBox 74"/>
           <p:cNvSpPr txBox="1"/>
           <p:nvPr/>
         </p:nvSpPr>
@@ -3521,7 +6230,7 @@
       </p:sp>
       <p:sp>
         <p:nvSpPr>
-          <p:cNvPr id="4" name="Rounded Rectangle 27"/>
+          <p:cNvPr id="4" name="Rounded Rectangle 75"/>
           <p:cNvSpPr/>
           <p:nvPr/>
         </p:nvSpPr>
@@ -3570,7 +6279,7 @@
       </p:sp>
       <p:sp>
         <p:nvSpPr>
-          <p:cNvPr id="5" name="TextBox 28"/>
+          <p:cNvPr id="5" name="TextBox 76"/>
           <p:cNvSpPr txBox="1"/>
           <p:nvPr/>
         </p:nvSpPr>
@@ -3627,7 +6336,7 @@
       </p:sp>
       <p:sp>
         <p:nvSpPr>
-          <p:cNvPr id="6" name="TextBox 29"/>
+          <p:cNvPr id="6" name="TextBox 77"/>
           <p:cNvSpPr txBox="1"/>
           <p:nvPr/>
         </p:nvSpPr>
@@ -3684,7 +6393,7 @@
       </p:sp>
       <p:sp>
         <p:nvSpPr>
-          <p:cNvPr id="7" name="Rounded Rectangle 30"/>
+          <p:cNvPr id="7" name="Rounded Rectangle 78"/>
           <p:cNvSpPr/>
           <p:nvPr/>
         </p:nvSpPr>
@@ -3733,7 +6442,7 @@
       </p:sp>
       <p:sp>
         <p:nvSpPr>
-          <p:cNvPr id="8" name="TextBox 31"/>
+          <p:cNvPr id="8" name="TextBox 79"/>
           <p:cNvSpPr txBox="1"/>
           <p:nvPr/>
         </p:nvSpPr>
@@ -3790,7 +6499,7 @@
       </p:sp>
       <p:sp>
         <p:nvSpPr>
-          <p:cNvPr id="9" name="TextBox 32"/>
+          <p:cNvPr id="9" name="TextBox 80"/>
           <p:cNvSpPr txBox="1"/>
           <p:nvPr/>
         </p:nvSpPr>
@@ -3847,7 +6556,7 @@
       </p:sp>
       <p:sp>
         <p:nvSpPr>
-          <p:cNvPr id="10" name="Rounded Rectangle 33"/>
+          <p:cNvPr id="10" name="Rounded Rectangle 81"/>
           <p:cNvSpPr/>
           <p:nvPr/>
         </p:nvSpPr>
@@ -3896,7 +6605,7 @@
       </p:sp>
       <p:sp>
         <p:nvSpPr>
-          <p:cNvPr id="11" name="TextBox 34"/>
+          <p:cNvPr id="11" name="TextBox 82"/>
           <p:cNvSpPr txBox="1"/>
           <p:nvPr/>
         </p:nvSpPr>
@@ -3953,7 +6662,7 @@
       </p:sp>
       <p:sp>
         <p:nvSpPr>
-          <p:cNvPr id="12" name="TextBox 35"/>
+          <p:cNvPr id="12" name="TextBox 83"/>
           <p:cNvSpPr txBox="1"/>
           <p:nvPr/>
         </p:nvSpPr>
@@ -4010,7 +6719,7 @@
       </p:sp>
       <p:sp>
         <p:nvSpPr>
-          <p:cNvPr id="13" name="Rounded Rectangle 36"/>
+          <p:cNvPr id="13" name="Rounded Rectangle 84"/>
           <p:cNvSpPr/>
           <p:nvPr/>
         </p:nvSpPr>
@@ -4059,7 +6768,7 @@
       </p:sp>
       <p:sp>
         <p:nvSpPr>
-          <p:cNvPr id="14" name="TextBox 37"/>
+          <p:cNvPr id="14" name="TextBox 85"/>
           <p:cNvSpPr txBox="1"/>
           <p:nvPr/>
         </p:nvSpPr>
@@ -4116,7 +6825,7 @@
       </p:sp>
       <p:sp>
         <p:nvSpPr>
-          <p:cNvPr id="15" name="TextBox 38"/>
+          <p:cNvPr id="15" name="TextBox 86"/>
           <p:cNvSpPr txBox="1"/>
           <p:nvPr/>
         </p:nvSpPr>
@@ -4173,7 +6882,7 @@
       </p:sp>
       <p:sp>
         <p:nvSpPr>
-          <p:cNvPr id="16" name="Rounded Rectangle 39"/>
+          <p:cNvPr id="16" name="Rounded Rectangle 87"/>
           <p:cNvSpPr/>
           <p:nvPr/>
         </p:nvSpPr>
@@ -4222,7 +6931,7 @@
       </p:sp>
       <p:sp>
         <p:nvSpPr>
-          <p:cNvPr id="17" name="TextBox 40"/>
+          <p:cNvPr id="17" name="TextBox 88"/>
           <p:cNvSpPr txBox="1"/>
           <p:nvPr/>
         </p:nvSpPr>
@@ -4279,7 +6988,7 @@
       </p:sp>
       <p:sp>
         <p:nvSpPr>
-          <p:cNvPr id="18" name="TextBox 41"/>
+          <p:cNvPr id="18" name="TextBox 89"/>
           <p:cNvSpPr txBox="1"/>
           <p:nvPr/>
         </p:nvSpPr>
@@ -4336,7 +7045,7 @@
       </p:sp>
       <p:sp>
         <p:nvSpPr>
-          <p:cNvPr id="19" name="Rounded Rectangle 42"/>
+          <p:cNvPr id="19" name="Rounded Rectangle 90"/>
           <p:cNvSpPr/>
           <p:nvPr/>
         </p:nvSpPr>
@@ -4385,7 +7094,7 @@
       </p:sp>
       <p:sp>
         <p:nvSpPr>
-          <p:cNvPr id="20" name="TextBox 43"/>
+          <p:cNvPr id="20" name="TextBox 91"/>
           <p:cNvSpPr txBox="1"/>
           <p:nvPr/>
         </p:nvSpPr>
@@ -4442,7 +7151,7 @@
       </p:sp>
       <p:sp>
         <p:nvSpPr>
-          <p:cNvPr id="21" name="TextBox 44"/>
+          <p:cNvPr id="21" name="TextBox 92"/>
           <p:cNvSpPr txBox="1"/>
           <p:nvPr/>
         </p:nvSpPr>
@@ -4485,7 +7194,7 @@
                 <a:latin typeface="Calibri"/>
                 <a:cs typeface="Calibri"/>
               </a:rPr>
-              <a:t>Writer is live</a:t>
+              <a:t>In your browser</a:t>
             </a:r>
             <a:endParaRPr lang="en-US" sz="1500" b="0" i="0" u="none" strike="noStrike" dirty="0">
               <a:solidFill>
@@ -4499,7 +7208,7 @@
       </p:sp>
       <p:sp>
         <p:nvSpPr>
-          <p:cNvPr id="22" name="TextBox 45"/>
+          <p:cNvPr id="22" name="TextBox 93"/>
           <p:cNvSpPr txBox="1"/>
           <p:nvPr/>
         </p:nvSpPr>
@@ -4542,7 +7251,7 @@
                 <a:latin typeface="Calibri"/>
                 <a:cs typeface="Calibri"/>
               </a:rPr>
-              <a:t>Writer is available on the web today.</a:t>
+              <a:t>Documents. Presentations. Spreadsheets.</a:t>
             </a:r>
             <a:endParaRPr lang="en-US" sz="1600" b="0" i="0" u="none" strike="noStrike" dirty="0">
               <a:solidFill>
@@ -4573,7 +7282,7 @@
                 <a:latin typeface="Calibri"/>
                 <a:cs typeface="Calibri"/>
               </a:rPr>
-              <a:t>More apps and platforms are on the way.</a:t>
+              <a:t>Across your devices. Built in the open.</a:t>
             </a:r>
             <a:endParaRPr lang="en-US" sz="1600" b="0" i="0" u="none" strike="noStrike" dirty="0">
               <a:solidFill>
@@ -4596,7 +7305,7 @@
 </p:sld>
 </file>
 
-<file path=ppt/slides/slide4.xml><?xml version="1.0" encoding="utf-8"?>
+<file path=ppt/slides/slide6.xml><?xml version="1.0" encoding="utf-8"?>
 <p:sld xmlns:a="http://schemas.openxmlformats.org/drawingml/2006/main" xmlns:r="http://schemas.openxmlformats.org/officeDocument/2006/relationships" xmlns:p="http://schemas.openxmlformats.org/presentationml/2006/main">
   <p:cSld>
     <p:bg>
@@ -4623,7 +7332,7 @@
       </p:grpSpPr>
       <p:sp>
         <p:nvSpPr>
-          <p:cNvPr id="2" name="TextBox 47"/>
+          <p:cNvPr id="2" name="TextBox 95"/>
           <p:cNvSpPr txBox="1"/>
           <p:nvPr/>
         </p:nvSpPr>
@@ -4666,7 +7375,7 @@
                 <a:latin typeface="Calibri"/>
                 <a:cs typeface="Calibri"/>
               </a:rPr>
-              <a:t>03  /  OPEN SOURCE. FROM THE START.</a:t>
+              <a:t>05  /  OPEN SOURCE. FROM THE START.</a:t>
             </a:r>
             <a:endParaRPr lang="en-US" sz="1300" b="1" i="0" u="none" strike="noStrike" dirty="0">
               <a:solidFill>
@@ -4680,7 +7389,7 @@
       </p:sp>
       <p:sp>
         <p:nvSpPr>
-          <p:cNvPr id="3" name="TextBox 48"/>
+          <p:cNvPr id="3" name="TextBox 96"/>
           <p:cNvSpPr txBox="1"/>
           <p:nvPr/>
         </p:nvSpPr>
@@ -4799,7 +7508,7 @@
       </p:sp>
       <p:sp>
         <p:nvSpPr>
-          <p:cNvPr id="4" name="TextBox 49"/>
+          <p:cNvPr id="4" name="TextBox 97"/>
           <p:cNvSpPr txBox="1"/>
           <p:nvPr/>
         </p:nvSpPr>
@@ -4887,7 +7596,7 @@
       </p:sp>
       <p:sp>
         <p:nvSpPr>
-          <p:cNvPr id="5" name="TextBox 50"/>
+          <p:cNvPr id="5" name="TextBox 98"/>
           <p:cNvSpPr txBox="1"/>
           <p:nvPr/>
         </p:nvSpPr>
@@ -4975,7 +7684,7 @@
       </p:sp>
       <p:sp>
         <p:nvSpPr>
-          <p:cNvPr id="6" name="TextBox 51"/>
+          <p:cNvPr id="6" name="TextBox 99"/>
           <p:cNvSpPr txBox="1"/>
           <p:nvPr/>
         </p:nvSpPr>
@@ -5018,7 +7727,7 @@
                 <a:latin typeface="Calibri"/>
                 <a:cs typeface="Calibri"/>
               </a:rPr>
-              <a:t>ONLY WRITER IS AVAILABLE SO FAR.</a:t>
+              <a:t>WRITER  ·  SLIDES  ·  SHEETS</a:t>
             </a:r>
             <a:endParaRPr lang="en-US" sz="1300" b="1" i="0" u="none" strike="noStrike" dirty="0">
               <a:solidFill>

</xml_diff>

<commit_message>
site: publish editable Writer illustration and live app links
Deploy the Office landing presentation from source e5c57321 with the tested runtime. Link Writer, Slides, and Sheets to their live apps and remove the story dialog. Version page assets and retain the prior runtime for cached clients.
</commit_message>
<xml_diff>
--- a/slides/landing-tall.pptx
+++ b/slides/landing-tall.pptx
@@ -1705,7 +1705,7 @@
             <a:spLocks noGrp="1"/>
           </p:cNvSpPr>
           <p:nvPr>
-            <p:ph idx="1"/>
+            <p:ph type="body" idx="1"/>
           </p:nvPr>
         </p:nvSpPr>
         <p:spPr>
@@ -3578,33 +3578,456 @@
           </a:p>
         </p:txBody>
       </p:sp>
-      <p:pic>
-        <p:nvPicPr>
-          <p:cNvPr id="5" name="Picture 28"/>
-          <p:cNvPicPr>
-            <a:picLocks noChangeAspect="1"/>
-          </p:cNvPicPr>
-          <p:nvPr/>
-        </p:nvPicPr>
-        <p:blipFill>
-          <a:blip r:embed="rIdImg1"/>
-          <a:stretch>
-            <a:fillRect/>
-          </a:stretch>
-        </p:blipFill>
-        <p:spPr>
-          <a:xfrm>
-            <a:off x="406400" y="3479800"/>
-            <a:ext cx="4902200" cy="3268129"/>
+      <p:sp>
+        <p:nvSpPr>
+          <p:cNvPr id="5" name="Rounded Rectangle 28"/>
+          <p:cNvSpPr/>
+          <p:nvPr/>
+        </p:nvSpPr>
+        <p:spPr>
+          <a:xfrm>
+            <a:off x="406400" y="3606800"/>
+            <a:ext cx="4902200" cy="3130967"/>
+          </a:xfrm>
+          <a:prstGeom prst="roundRect">
+            <a:avLst/>
+          </a:prstGeom>
+          <a:solidFill>
+            <a:srgbClr val="FFFFFF"/>
+          </a:solidFill>
+          <a:ln>
+            <a:noFill/>
+          </a:ln>
+        </p:spPr>
+        <p:txBody>
+          <a:bodyPr wrap="square" lIns="91440" tIns="45720" rIns="91440" bIns="45720" anchor="ctr" rtlCol="0">
+            <a:noAutofit/>
+          </a:bodyPr>
+          <a:lstStyle/>
+          <a:p>
+            <a:pPr algn="ctr" marL="0" indent="0">
+              <a:lnSpc>
+                <a:spcPct val="100000"/>
+              </a:lnSpc>
+              <a:spcBef>
+                <a:spcPts val="0"/>
+              </a:spcBef>
+              <a:spcAft>
+                <a:spcPts val="0"/>
+              </a:spcAft>
+              <a:buNone/>
+            </a:pPr>
+            <a:endParaRPr lang="en-US" sz="1800" b="0" i="0" u="none" strike="noStrike" dirty="0">
+              <a:solidFill>
+                <a:srgbClr val="FFFFFF"/>
+              </a:solidFill>
+              <a:latin typeface="Calibri"/>
+              <a:cs typeface="Calibri"/>
+            </a:endParaRPr>
+          </a:p>
+        </p:txBody>
+      </p:sp>
+      <p:sp>
+        <p:nvSpPr>
+          <p:cNvPr id="6" name="TextBox 29"/>
+          <p:cNvSpPr txBox="1"/>
+          <p:nvPr/>
+        </p:nvSpPr>
+        <p:spPr>
+          <a:xfrm>
+            <a:off x="719497" y="3848332"/>
+            <a:ext cx="4276007" cy="5295668"/>
           </a:xfrm>
           <a:prstGeom prst="rect">
             <a:avLst/>
           </a:prstGeom>
-        </p:spPr>
-      </p:pic>
-      <p:sp>
-        <p:nvSpPr>
-          <p:cNvPr id="6" name="TextBox 29"/>
+          <a:noFill/>
+          <a:ln>
+            <a:noFill/>
+          </a:ln>
+        </p:spPr>
+        <p:txBody>
+          <a:bodyPr wrap="square" lIns="0" tIns="0" rIns="0" bIns="0" anchor="t" rtlCol="0">
+            <a:spAutoFit/>
+          </a:bodyPr>
+          <a:lstStyle/>
+          <a:p>
+            <a:pPr algn="l" marL="0" indent="0">
+              <a:lnSpc>
+                <a:spcPct val="100000"/>
+              </a:lnSpc>
+              <a:spcBef>
+                <a:spcPts val="0"/>
+              </a:spcBef>
+              <a:spcAft>
+                <a:spcPts val="0"/>
+              </a:spcAft>
+              <a:buNone/>
+            </a:pPr>
+            <a:r>
+              <a:rPr lang="en-US" sz="1057" b="1" i="0" u="none" strike="noStrike" dirty="0">
+                <a:solidFill>
+                  <a:srgbClr val="2449DF"/>
+                </a:solidFill>
+                <a:latin typeface="Calibri"/>
+                <a:cs typeface="Calibri"/>
+              </a:rPr>
+              <a:t>PROJECT NOTES</a:t>
+            </a:r>
+            <a:endParaRPr lang="en-US" sz="1057" b="1" i="0" u="none" strike="noStrike" dirty="0">
+              <a:solidFill>
+                <a:srgbClr val="2449DF"/>
+              </a:solidFill>
+              <a:latin typeface="Calibri"/>
+              <a:cs typeface="Calibri"/>
+            </a:endParaRPr>
+          </a:p>
+        </p:txBody>
+      </p:sp>
+      <p:sp>
+        <p:nvSpPr>
+          <p:cNvPr id="7" name="TextBox 30"/>
+          <p:cNvSpPr txBox="1"/>
+          <p:nvPr/>
+        </p:nvSpPr>
+        <p:spPr>
+          <a:xfrm>
+            <a:off x="719497" y="4188265"/>
+            <a:ext cx="4276007" cy="4955735"/>
+          </a:xfrm>
+          <a:prstGeom prst="rect">
+            <a:avLst/>
+          </a:prstGeom>
+          <a:noFill/>
+          <a:ln>
+            <a:noFill/>
+          </a:ln>
+        </p:spPr>
+        <p:txBody>
+          <a:bodyPr wrap="square" lIns="0" tIns="0" rIns="0" bIns="0" anchor="t" rtlCol="0">
+            <a:spAutoFit/>
+          </a:bodyPr>
+          <a:lstStyle/>
+          <a:p>
+            <a:pPr algn="l" marL="0" indent="0">
+              <a:lnSpc>
+                <a:spcPct val="100000"/>
+              </a:lnSpc>
+              <a:spcBef>
+                <a:spcPts val="0"/>
+              </a:spcBef>
+              <a:spcAft>
+                <a:spcPts val="0"/>
+              </a:spcAft>
+              <a:buNone/>
+            </a:pPr>
+            <a:r>
+              <a:rPr lang="en-US" sz="2536" b="1" i="0" u="none" strike="noStrike" dirty="0">
+                <a:solidFill>
+                  <a:srgbClr val="132442"/>
+                </a:solidFill>
+                <a:latin typeface="Calibri"/>
+                <a:cs typeface="Calibri"/>
+              </a:rPr>
+              <a:t>Your next big idea.</a:t>
+            </a:r>
+            <a:endParaRPr lang="en-US" sz="2536" b="1" i="0" u="none" strike="noStrike" dirty="0">
+              <a:solidFill>
+                <a:srgbClr val="132442"/>
+              </a:solidFill>
+              <a:latin typeface="Calibri"/>
+              <a:cs typeface="Calibri"/>
+            </a:endParaRPr>
+          </a:p>
+        </p:txBody>
+      </p:sp>
+      <p:sp>
+        <p:nvSpPr>
+          <p:cNvPr id="8" name="Rectangle 31"/>
+          <p:cNvSpPr/>
+          <p:nvPr/>
+        </p:nvSpPr>
+        <p:spPr>
+          <a:xfrm>
+            <a:off x="719497" y="4725003"/>
+            <a:ext cx="4276007" cy="26837"/>
+          </a:xfrm>
+          <a:prstGeom prst="rect">
+            <a:avLst/>
+          </a:prstGeom>
+          <a:solidFill>
+            <a:srgbClr val="2449DF"/>
+          </a:solidFill>
+          <a:ln>
+            <a:noFill/>
+          </a:ln>
+        </p:spPr>
+        <p:txBody>
+          <a:bodyPr wrap="square" lIns="91440" tIns="45720" rIns="91440" bIns="45720" anchor="ctr" rtlCol="0">
+            <a:noAutofit/>
+          </a:bodyPr>
+          <a:lstStyle/>
+          <a:p>
+            <a:pPr algn="ctr" marL="0" indent="0">
+              <a:lnSpc>
+                <a:spcPct val="100000"/>
+              </a:lnSpc>
+              <a:spcBef>
+                <a:spcPts val="0"/>
+              </a:spcBef>
+              <a:spcAft>
+                <a:spcPts val="0"/>
+              </a:spcAft>
+              <a:buNone/>
+            </a:pPr>
+            <a:endParaRPr lang="en-US" sz="1800" b="0" i="0" u="none" strike="noStrike" dirty="0">
+              <a:solidFill>
+                <a:srgbClr val="FFFFFF"/>
+              </a:solidFill>
+              <a:latin typeface="Calibri"/>
+              <a:cs typeface="Calibri"/>
+            </a:endParaRPr>
+          </a:p>
+        </p:txBody>
+      </p:sp>
+      <p:sp>
+        <p:nvSpPr>
+          <p:cNvPr id="9" name="TextBox 32"/>
+          <p:cNvSpPr txBox="1"/>
+          <p:nvPr/>
+        </p:nvSpPr>
+        <p:spPr>
+          <a:xfrm>
+            <a:off x="719497" y="4975480"/>
+            <a:ext cx="4276007" cy="4168520"/>
+          </a:xfrm>
+          <a:prstGeom prst="rect">
+            <a:avLst/>
+          </a:prstGeom>
+          <a:noFill/>
+          <a:ln>
+            <a:noFill/>
+          </a:ln>
+        </p:spPr>
+        <p:txBody>
+          <a:bodyPr wrap="square" lIns="0" tIns="0" rIns="0" bIns="0" anchor="t" rtlCol="0">
+            <a:spAutoFit/>
+          </a:bodyPr>
+          <a:lstStyle/>
+          <a:p>
+            <a:pPr algn="l" marL="0" indent="0">
+              <a:lnSpc>
+                <a:spcPct val="100000"/>
+              </a:lnSpc>
+              <a:spcBef>
+                <a:spcPts val="0"/>
+              </a:spcBef>
+              <a:spcAft>
+                <a:spcPts val="0"/>
+              </a:spcAft>
+              <a:buNone/>
+            </a:pPr>
+            <a:r>
+              <a:rPr lang="en-US" sz="1761" b="0" i="0" u="none" strike="noStrike" dirty="0">
+                <a:solidFill>
+                  <a:srgbClr val="536782"/>
+                </a:solidFill>
+                <a:latin typeface="Calibri"/>
+                <a:cs typeface="Calibri"/>
+              </a:rPr>
+              <a:t>Start with a thought.</a:t>
+            </a:r>
+            <a:endParaRPr lang="en-US" sz="1761" b="0" i="0" u="none" strike="noStrike" dirty="0">
+              <a:solidFill>
+                <a:srgbClr val="536782"/>
+              </a:solidFill>
+              <a:latin typeface="Calibri"/>
+              <a:cs typeface="Calibri"/>
+            </a:endParaRPr>
+          </a:p>
+          <a:p>
+            <a:pPr algn="l" marL="0" indent="0">
+              <a:lnSpc>
+                <a:spcPct val="100000"/>
+              </a:lnSpc>
+              <a:spcBef>
+                <a:spcPts val="0"/>
+              </a:spcBef>
+              <a:spcAft>
+                <a:spcPts val="0"/>
+              </a:spcAft>
+              <a:buNone/>
+            </a:pPr>
+            <a:r>
+              <a:rPr lang="en-US" sz="1761" b="0" i="0" u="none" strike="noStrike" dirty="0">
+                <a:solidFill>
+                  <a:srgbClr val="536782"/>
+                </a:solidFill>
+                <a:latin typeface="Calibri"/>
+                <a:cs typeface="Calibri"/>
+              </a:rPr>
+              <a:t>Give it room to grow.</a:t>
+            </a:r>
+            <a:endParaRPr lang="en-US" sz="1761" b="0" i="0" u="none" strike="noStrike" dirty="0">
+              <a:solidFill>
+                <a:srgbClr val="536782"/>
+              </a:solidFill>
+              <a:latin typeface="Calibri"/>
+              <a:cs typeface="Calibri"/>
+            </a:endParaRPr>
+          </a:p>
+        </p:txBody>
+      </p:sp>
+      <p:sp>
+        <p:nvSpPr>
+          <p:cNvPr id="10" name="Rounded Rectangle 33"/>
+          <p:cNvSpPr/>
+          <p:nvPr/>
+        </p:nvSpPr>
+        <p:spPr>
+          <a:xfrm>
+            <a:off x="719497" y="5843205"/>
+            <a:ext cx="3846617" cy="71565"/>
+          </a:xfrm>
+          <a:prstGeom prst="roundRect">
+            <a:avLst/>
+          </a:prstGeom>
+          <a:solidFill>
+            <a:srgbClr val="E3E9FA"/>
+          </a:solidFill>
+          <a:ln>
+            <a:noFill/>
+          </a:ln>
+        </p:spPr>
+        <p:txBody>
+          <a:bodyPr wrap="square" lIns="91440" tIns="45720" rIns="91440" bIns="45720" anchor="ctr" rtlCol="0">
+            <a:noAutofit/>
+          </a:bodyPr>
+          <a:lstStyle/>
+          <a:p>
+            <a:pPr algn="ctr" marL="0" indent="0">
+              <a:lnSpc>
+                <a:spcPct val="100000"/>
+              </a:lnSpc>
+              <a:spcBef>
+                <a:spcPts val="0"/>
+              </a:spcBef>
+              <a:spcAft>
+                <a:spcPts val="0"/>
+              </a:spcAft>
+              <a:buNone/>
+            </a:pPr>
+            <a:endParaRPr lang="en-US" sz="1800" b="0" i="0" u="none" strike="noStrike" dirty="0">
+              <a:solidFill>
+                <a:srgbClr val="FFFFFF"/>
+              </a:solidFill>
+              <a:latin typeface="Calibri"/>
+              <a:cs typeface="Calibri"/>
+            </a:endParaRPr>
+          </a:p>
+        </p:txBody>
+      </p:sp>
+      <p:sp>
+        <p:nvSpPr>
+          <p:cNvPr id="11" name="Rounded Rectangle 34"/>
+          <p:cNvSpPr/>
+          <p:nvPr/>
+        </p:nvSpPr>
+        <p:spPr>
+          <a:xfrm>
+            <a:off x="719497" y="6057900"/>
+            <a:ext cx="4276007" cy="71565"/>
+          </a:xfrm>
+          <a:prstGeom prst="roundRect">
+            <a:avLst/>
+          </a:prstGeom>
+          <a:solidFill>
+            <a:srgbClr val="E3E9FA"/>
+          </a:solidFill>
+          <a:ln>
+            <a:noFill/>
+          </a:ln>
+        </p:spPr>
+        <p:txBody>
+          <a:bodyPr wrap="square" lIns="91440" tIns="45720" rIns="91440" bIns="45720" anchor="ctr" rtlCol="0">
+            <a:noAutofit/>
+          </a:bodyPr>
+          <a:lstStyle/>
+          <a:p>
+            <a:pPr algn="ctr" marL="0" indent="0">
+              <a:lnSpc>
+                <a:spcPct val="100000"/>
+              </a:lnSpc>
+              <a:spcBef>
+                <a:spcPts val="0"/>
+              </a:spcBef>
+              <a:spcAft>
+                <a:spcPts val="0"/>
+              </a:spcAft>
+              <a:buNone/>
+            </a:pPr>
+            <a:endParaRPr lang="en-US" sz="1800" b="0" i="0" u="none" strike="noStrike" dirty="0">
+              <a:solidFill>
+                <a:srgbClr val="FFFFFF"/>
+              </a:solidFill>
+              <a:latin typeface="Calibri"/>
+              <a:cs typeface="Calibri"/>
+            </a:endParaRPr>
+          </a:p>
+        </p:txBody>
+      </p:sp>
+      <p:sp>
+        <p:nvSpPr>
+          <p:cNvPr id="12" name="Rounded Rectangle 35"/>
+          <p:cNvSpPr/>
+          <p:nvPr/>
+        </p:nvSpPr>
+        <p:spPr>
+          <a:xfrm>
+            <a:off x="719497" y="6272595"/>
+            <a:ext cx="2952055" cy="71565"/>
+          </a:xfrm>
+          <a:prstGeom prst="roundRect">
+            <a:avLst/>
+          </a:prstGeom>
+          <a:solidFill>
+            <a:srgbClr val="E3E9FA"/>
+          </a:solidFill>
+          <a:ln>
+            <a:noFill/>
+          </a:ln>
+        </p:spPr>
+        <p:txBody>
+          <a:bodyPr wrap="square" lIns="91440" tIns="45720" rIns="91440" bIns="45720" anchor="ctr" rtlCol="0">
+            <a:noAutofit/>
+          </a:bodyPr>
+          <a:lstStyle/>
+          <a:p>
+            <a:pPr algn="ctr" marL="0" indent="0">
+              <a:lnSpc>
+                <a:spcPct val="100000"/>
+              </a:lnSpc>
+              <a:spcBef>
+                <a:spcPts val="0"/>
+              </a:spcBef>
+              <a:spcAft>
+                <a:spcPts val="0"/>
+              </a:spcAft>
+              <a:buNone/>
+            </a:pPr>
+            <a:endParaRPr lang="en-US" sz="1800" b="0" i="0" u="none" strike="noStrike" dirty="0">
+              <a:solidFill>
+                <a:srgbClr val="FFFFFF"/>
+              </a:solidFill>
+              <a:latin typeface="Calibri"/>
+              <a:cs typeface="Calibri"/>
+            </a:endParaRPr>
+          </a:p>
+        </p:txBody>
+      </p:sp>
+      <p:sp>
+        <p:nvSpPr>
+          <p:cNvPr id="13" name="TextBox 36"/>
           <p:cNvSpPr txBox="1"/>
           <p:nvPr/>
         </p:nvSpPr>
@@ -3697,7 +4120,7 @@
       </p:grpSpPr>
       <p:sp>
         <p:nvSpPr>
-          <p:cNvPr id="2" name="TextBox 31"/>
+          <p:cNvPr id="2" name="TextBox 38"/>
           <p:cNvSpPr txBox="1"/>
           <p:nvPr/>
         </p:nvSpPr>
@@ -3754,7 +4177,7 @@
       </p:sp>
       <p:sp>
         <p:nvSpPr>
-          <p:cNvPr id="3" name="TextBox 32"/>
+          <p:cNvPr id="3" name="TextBox 39"/>
           <p:cNvSpPr txBox="1"/>
           <p:nvPr/>
         </p:nvSpPr>
@@ -3842,7 +4265,7 @@
       </p:sp>
       <p:sp>
         <p:nvSpPr>
-          <p:cNvPr id="4" name="TextBox 33"/>
+          <p:cNvPr id="4" name="TextBox 40"/>
           <p:cNvSpPr txBox="1"/>
           <p:nvPr/>
         </p:nvSpPr>
@@ -3930,7 +4353,7 @@
       </p:sp>
       <p:sp>
         <p:nvSpPr>
-          <p:cNvPr id="5" name="Rounded Rectangle 34"/>
+          <p:cNvPr id="5" name="Rounded Rectangle 41"/>
           <p:cNvSpPr/>
           <p:nvPr/>
         </p:nvSpPr>
@@ -3979,7 +4402,7 @@
       </p:sp>
       <p:sp>
         <p:nvSpPr>
-          <p:cNvPr id="6" name="TextBox 35"/>
+          <p:cNvPr id="6" name="TextBox 42"/>
           <p:cNvSpPr txBox="1"/>
           <p:nvPr/>
         </p:nvSpPr>
@@ -4036,7 +4459,7 @@
       </p:sp>
       <p:sp>
         <p:nvSpPr>
-          <p:cNvPr id="7" name="TextBox 36"/>
+          <p:cNvPr id="7" name="TextBox 43"/>
           <p:cNvSpPr txBox="1"/>
           <p:nvPr/>
         </p:nvSpPr>
@@ -4093,7 +4516,7 @@
       </p:sp>
       <p:sp>
         <p:nvSpPr>
-          <p:cNvPr id="8" name="Rounded Rectangle 37"/>
+          <p:cNvPr id="8" name="Rounded Rectangle 44"/>
           <p:cNvSpPr/>
           <p:nvPr/>
         </p:nvSpPr>
@@ -4142,7 +4565,7 @@
       </p:sp>
       <p:sp>
         <p:nvSpPr>
-          <p:cNvPr id="9" name="Rounded Rectangle 38"/>
+          <p:cNvPr id="9" name="Rounded Rectangle 45"/>
           <p:cNvSpPr/>
           <p:nvPr/>
         </p:nvSpPr>
@@ -4191,7 +4614,7 @@
       </p:sp>
       <p:sp>
         <p:nvSpPr>
-          <p:cNvPr id="10" name="Rounded Rectangle 39"/>
+          <p:cNvPr id="10" name="Rounded Rectangle 46"/>
           <p:cNvSpPr/>
           <p:nvPr/>
         </p:nvSpPr>
@@ -4240,7 +4663,7 @@
       </p:sp>
       <p:sp>
         <p:nvSpPr>
-          <p:cNvPr id="11" name="TextBox 40"/>
+          <p:cNvPr id="11" name="TextBox 47"/>
           <p:cNvSpPr txBox="1"/>
           <p:nvPr/>
         </p:nvSpPr>
@@ -4297,7 +4720,7 @@
       </p:sp>
       <p:sp>
         <p:nvSpPr>
-          <p:cNvPr id="12" name="TextBox 41"/>
+          <p:cNvPr id="12" name="TextBox 48"/>
           <p:cNvSpPr txBox="1"/>
           <p:nvPr/>
         </p:nvSpPr>
@@ -4354,7 +4777,7 @@
       </p:sp>
       <p:sp>
         <p:nvSpPr>
-          <p:cNvPr id="13" name="TextBox 42"/>
+          <p:cNvPr id="13" name="TextBox 49"/>
           <p:cNvSpPr txBox="1"/>
           <p:nvPr/>
         </p:nvSpPr>
@@ -4411,7 +4834,7 @@
       </p:sp>
       <p:sp>
         <p:nvSpPr>
-          <p:cNvPr id="14" name="TextBox 43"/>
+          <p:cNvPr id="14" name="TextBox 50"/>
           <p:cNvSpPr txBox="1"/>
           <p:nvPr/>
         </p:nvSpPr>
@@ -4504,7 +4927,7 @@
       </p:grpSpPr>
       <p:sp>
         <p:nvSpPr>
-          <p:cNvPr id="2" name="TextBox 45"/>
+          <p:cNvPr id="2" name="TextBox 52"/>
           <p:cNvSpPr txBox="1"/>
           <p:nvPr/>
         </p:nvSpPr>
@@ -4561,7 +4984,7 @@
       </p:sp>
       <p:sp>
         <p:nvSpPr>
-          <p:cNvPr id="3" name="TextBox 46"/>
+          <p:cNvPr id="3" name="TextBox 53"/>
           <p:cNvSpPr txBox="1"/>
           <p:nvPr/>
         </p:nvSpPr>
@@ -4649,7 +5072,7 @@
       </p:sp>
       <p:sp>
         <p:nvSpPr>
-          <p:cNvPr id="4" name="TextBox 47"/>
+          <p:cNvPr id="4" name="TextBox 54"/>
           <p:cNvSpPr txBox="1"/>
           <p:nvPr/>
         </p:nvSpPr>
@@ -4737,7 +5160,7 @@
       </p:sp>
       <p:sp>
         <p:nvSpPr>
-          <p:cNvPr id="5" name="Rounded Rectangle 48"/>
+          <p:cNvPr id="5" name="Rounded Rectangle 55"/>
           <p:cNvSpPr/>
           <p:nvPr/>
         </p:nvSpPr>
@@ -4786,7 +5209,7 @@
       </p:sp>
       <p:sp>
         <p:nvSpPr>
-          <p:cNvPr id="6" name="Rounded Rectangle 49"/>
+          <p:cNvPr id="6" name="Rounded Rectangle 56"/>
           <p:cNvSpPr/>
           <p:nvPr/>
         </p:nvSpPr>
@@ -4835,7 +5258,7 @@
       </p:sp>
       <p:sp>
         <p:nvSpPr>
-          <p:cNvPr id="7" name="TextBox 50"/>
+          <p:cNvPr id="7" name="TextBox 57"/>
           <p:cNvSpPr txBox="1"/>
           <p:nvPr/>
         </p:nvSpPr>
@@ -4892,7 +5315,7 @@
       </p:sp>
       <p:sp>
         <p:nvSpPr>
-          <p:cNvPr id="8" name="Rectangle 51"/>
+          <p:cNvPr id="8" name="Rectangle 58"/>
           <p:cNvSpPr/>
           <p:nvPr/>
         </p:nvSpPr>
@@ -4941,7 +5364,7 @@
       </p:sp>
       <p:sp>
         <p:nvSpPr>
-          <p:cNvPr id="9" name="TextBox 52"/>
+          <p:cNvPr id="9" name="TextBox 59"/>
           <p:cNvSpPr txBox="1"/>
           <p:nvPr/>
         </p:nvSpPr>
@@ -4998,7 +5421,7 @@
       </p:sp>
       <p:sp>
         <p:nvSpPr>
-          <p:cNvPr id="10" name="TextBox 53"/>
+          <p:cNvPr id="10" name="TextBox 60"/>
           <p:cNvSpPr txBox="1"/>
           <p:nvPr/>
         </p:nvSpPr>
@@ -5055,7 +5478,7 @@
       </p:sp>
       <p:sp>
         <p:nvSpPr>
-          <p:cNvPr id="11" name="TextBox 54"/>
+          <p:cNvPr id="11" name="TextBox 61"/>
           <p:cNvSpPr txBox="1"/>
           <p:nvPr/>
         </p:nvSpPr>
@@ -5112,7 +5535,7 @@
       </p:sp>
       <p:sp>
         <p:nvSpPr>
-          <p:cNvPr id="12" name="Rectangle 55"/>
+          <p:cNvPr id="12" name="Rectangle 62"/>
           <p:cNvSpPr/>
           <p:nvPr/>
         </p:nvSpPr>
@@ -5161,7 +5584,7 @@
       </p:sp>
       <p:sp>
         <p:nvSpPr>
-          <p:cNvPr id="13" name="TextBox 56"/>
+          <p:cNvPr id="13" name="TextBox 63"/>
           <p:cNvSpPr txBox="1"/>
           <p:nvPr/>
         </p:nvSpPr>
@@ -5218,7 +5641,7 @@
       </p:sp>
       <p:sp>
         <p:nvSpPr>
-          <p:cNvPr id="14" name="TextBox 57"/>
+          <p:cNvPr id="14" name="TextBox 64"/>
           <p:cNvSpPr txBox="1"/>
           <p:nvPr/>
         </p:nvSpPr>
@@ -5275,7 +5698,7 @@
       </p:sp>
       <p:sp>
         <p:nvSpPr>
-          <p:cNvPr id="15" name="TextBox 58"/>
+          <p:cNvPr id="15" name="TextBox 65"/>
           <p:cNvSpPr txBox="1"/>
           <p:nvPr/>
         </p:nvSpPr>
@@ -5332,7 +5755,7 @@
       </p:sp>
       <p:sp>
         <p:nvSpPr>
-          <p:cNvPr id="16" name="Rectangle 59"/>
+          <p:cNvPr id="16" name="Rectangle 66"/>
           <p:cNvSpPr/>
           <p:nvPr/>
         </p:nvSpPr>
@@ -5381,7 +5804,7 @@
       </p:sp>
       <p:sp>
         <p:nvSpPr>
-          <p:cNvPr id="17" name="TextBox 60"/>
+          <p:cNvPr id="17" name="TextBox 67"/>
           <p:cNvSpPr txBox="1"/>
           <p:nvPr/>
         </p:nvSpPr>
@@ -5438,7 +5861,7 @@
       </p:sp>
       <p:sp>
         <p:nvSpPr>
-          <p:cNvPr id="18" name="TextBox 61"/>
+          <p:cNvPr id="18" name="TextBox 68"/>
           <p:cNvSpPr txBox="1"/>
           <p:nvPr/>
         </p:nvSpPr>
@@ -5495,7 +5918,7 @@
       </p:sp>
       <p:sp>
         <p:nvSpPr>
-          <p:cNvPr id="19" name="TextBox 62"/>
+          <p:cNvPr id="19" name="TextBox 69"/>
           <p:cNvSpPr txBox="1"/>
           <p:nvPr/>
         </p:nvSpPr>
@@ -5552,7 +5975,7 @@
       </p:sp>
       <p:sp>
         <p:nvSpPr>
-          <p:cNvPr id="20" name="Rectangle 63"/>
+          <p:cNvPr id="20" name="Rectangle 70"/>
           <p:cNvSpPr/>
           <p:nvPr/>
         </p:nvSpPr>
@@ -5601,7 +6024,7 @@
       </p:sp>
       <p:sp>
         <p:nvSpPr>
-          <p:cNvPr id="21" name="TextBox 64"/>
+          <p:cNvPr id="21" name="TextBox 71"/>
           <p:cNvSpPr txBox="1"/>
           <p:nvPr/>
         </p:nvSpPr>
@@ -5658,7 +6081,7 @@
       </p:sp>
       <p:sp>
         <p:nvSpPr>
-          <p:cNvPr id="22" name="TextBox 65"/>
+          <p:cNvPr id="22" name="TextBox 72"/>
           <p:cNvSpPr txBox="1"/>
           <p:nvPr/>
         </p:nvSpPr>
@@ -5715,7 +6138,7 @@
       </p:sp>
       <p:sp>
         <p:nvSpPr>
-          <p:cNvPr id="23" name="TextBox 66"/>
+          <p:cNvPr id="23" name="TextBox 73"/>
           <p:cNvSpPr txBox="1"/>
           <p:nvPr/>
         </p:nvSpPr>
@@ -5772,7 +6195,7 @@
       </p:sp>
       <p:sp>
         <p:nvSpPr>
-          <p:cNvPr id="24" name="Rectangle 67"/>
+          <p:cNvPr id="24" name="Rectangle 74"/>
           <p:cNvSpPr/>
           <p:nvPr/>
         </p:nvSpPr>
@@ -5821,7 +6244,7 @@
       </p:sp>
       <p:sp>
         <p:nvSpPr>
-          <p:cNvPr id="25" name="TextBox 68"/>
+          <p:cNvPr id="25" name="TextBox 75"/>
           <p:cNvSpPr txBox="1"/>
           <p:nvPr/>
         </p:nvSpPr>
@@ -5878,7 +6301,7 @@
       </p:sp>
       <p:sp>
         <p:nvSpPr>
-          <p:cNvPr id="26" name="TextBox 69"/>
+          <p:cNvPr id="26" name="TextBox 76"/>
           <p:cNvSpPr txBox="1"/>
           <p:nvPr/>
         </p:nvSpPr>
@@ -5935,7 +6358,7 @@
       </p:sp>
       <p:sp>
         <p:nvSpPr>
-          <p:cNvPr id="27" name="TextBox 70"/>
+          <p:cNvPr id="27" name="TextBox 77"/>
           <p:cNvSpPr txBox="1"/>
           <p:nvPr/>
         </p:nvSpPr>
@@ -5992,7 +6415,7 @@
       </p:sp>
       <p:sp>
         <p:nvSpPr>
-          <p:cNvPr id="28" name="TextBox 71"/>
+          <p:cNvPr id="28" name="TextBox 78"/>
           <p:cNvSpPr txBox="1"/>
           <p:nvPr/>
         </p:nvSpPr>
@@ -6085,7 +6508,7 @@
       </p:grpSpPr>
       <p:sp>
         <p:nvSpPr>
-          <p:cNvPr id="2" name="TextBox 73"/>
+          <p:cNvPr id="2" name="TextBox 80"/>
           <p:cNvSpPr txBox="1"/>
           <p:nvPr/>
         </p:nvSpPr>
@@ -6142,7 +6565,7 @@
       </p:sp>
       <p:sp>
         <p:nvSpPr>
-          <p:cNvPr id="3" name="TextBox 74"/>
+          <p:cNvPr id="3" name="TextBox 81"/>
           <p:cNvSpPr txBox="1"/>
           <p:nvPr/>
         </p:nvSpPr>
@@ -6230,7 +6653,7 @@
       </p:sp>
       <p:sp>
         <p:nvSpPr>
-          <p:cNvPr id="4" name="Rounded Rectangle 75"/>
+          <p:cNvPr id="4" name="Rounded Rectangle 82"/>
           <p:cNvSpPr/>
           <p:nvPr/>
         </p:nvSpPr>
@@ -6279,7 +6702,7 @@
       </p:sp>
       <p:sp>
         <p:nvSpPr>
-          <p:cNvPr id="5" name="TextBox 76"/>
+          <p:cNvPr id="5" name="TextBox 83"/>
           <p:cNvSpPr txBox="1"/>
           <p:nvPr/>
         </p:nvSpPr>
@@ -6336,7 +6759,7 @@
       </p:sp>
       <p:sp>
         <p:nvSpPr>
-          <p:cNvPr id="6" name="TextBox 77"/>
+          <p:cNvPr id="6" name="TextBox 84"/>
           <p:cNvSpPr txBox="1"/>
           <p:nvPr/>
         </p:nvSpPr>
@@ -6393,7 +6816,7 @@
       </p:sp>
       <p:sp>
         <p:nvSpPr>
-          <p:cNvPr id="7" name="Rounded Rectangle 78"/>
+          <p:cNvPr id="7" name="Rounded Rectangle 85"/>
           <p:cNvSpPr/>
           <p:nvPr/>
         </p:nvSpPr>
@@ -6442,7 +6865,7 @@
       </p:sp>
       <p:sp>
         <p:nvSpPr>
-          <p:cNvPr id="8" name="TextBox 79"/>
+          <p:cNvPr id="8" name="TextBox 86"/>
           <p:cNvSpPr txBox="1"/>
           <p:nvPr/>
         </p:nvSpPr>
@@ -6499,7 +6922,7 @@
       </p:sp>
       <p:sp>
         <p:nvSpPr>
-          <p:cNvPr id="9" name="TextBox 80"/>
+          <p:cNvPr id="9" name="TextBox 87"/>
           <p:cNvSpPr txBox="1"/>
           <p:nvPr/>
         </p:nvSpPr>
@@ -6556,7 +6979,7 @@
       </p:sp>
       <p:sp>
         <p:nvSpPr>
-          <p:cNvPr id="10" name="Rounded Rectangle 81"/>
+          <p:cNvPr id="10" name="Rounded Rectangle 88"/>
           <p:cNvSpPr/>
           <p:nvPr/>
         </p:nvSpPr>
@@ -6605,7 +7028,7 @@
       </p:sp>
       <p:sp>
         <p:nvSpPr>
-          <p:cNvPr id="11" name="TextBox 82"/>
+          <p:cNvPr id="11" name="TextBox 89"/>
           <p:cNvSpPr txBox="1"/>
           <p:nvPr/>
         </p:nvSpPr>
@@ -6662,7 +7085,7 @@
       </p:sp>
       <p:sp>
         <p:nvSpPr>
-          <p:cNvPr id="12" name="TextBox 83"/>
+          <p:cNvPr id="12" name="TextBox 90"/>
           <p:cNvSpPr txBox="1"/>
           <p:nvPr/>
         </p:nvSpPr>
@@ -6719,7 +7142,7 @@
       </p:sp>
       <p:sp>
         <p:nvSpPr>
-          <p:cNvPr id="13" name="Rounded Rectangle 84"/>
+          <p:cNvPr id="13" name="Rounded Rectangle 91"/>
           <p:cNvSpPr/>
           <p:nvPr/>
         </p:nvSpPr>
@@ -6768,7 +7191,7 @@
       </p:sp>
       <p:sp>
         <p:nvSpPr>
-          <p:cNvPr id="14" name="TextBox 85"/>
+          <p:cNvPr id="14" name="TextBox 92"/>
           <p:cNvSpPr txBox="1"/>
           <p:nvPr/>
         </p:nvSpPr>
@@ -6825,7 +7248,7 @@
       </p:sp>
       <p:sp>
         <p:nvSpPr>
-          <p:cNvPr id="15" name="TextBox 86"/>
+          <p:cNvPr id="15" name="TextBox 93"/>
           <p:cNvSpPr txBox="1"/>
           <p:nvPr/>
         </p:nvSpPr>
@@ -6882,7 +7305,7 @@
       </p:sp>
       <p:sp>
         <p:nvSpPr>
-          <p:cNvPr id="16" name="Rounded Rectangle 87"/>
+          <p:cNvPr id="16" name="Rounded Rectangle 94"/>
           <p:cNvSpPr/>
           <p:nvPr/>
         </p:nvSpPr>
@@ -6931,7 +7354,7 @@
       </p:sp>
       <p:sp>
         <p:nvSpPr>
-          <p:cNvPr id="17" name="TextBox 88"/>
+          <p:cNvPr id="17" name="TextBox 95"/>
           <p:cNvSpPr txBox="1"/>
           <p:nvPr/>
         </p:nvSpPr>
@@ -6988,7 +7411,7 @@
       </p:sp>
       <p:sp>
         <p:nvSpPr>
-          <p:cNvPr id="18" name="TextBox 89"/>
+          <p:cNvPr id="18" name="TextBox 96"/>
           <p:cNvSpPr txBox="1"/>
           <p:nvPr/>
         </p:nvSpPr>
@@ -7045,7 +7468,7 @@
       </p:sp>
       <p:sp>
         <p:nvSpPr>
-          <p:cNvPr id="19" name="Rounded Rectangle 90"/>
+          <p:cNvPr id="19" name="Rounded Rectangle 97"/>
           <p:cNvSpPr/>
           <p:nvPr/>
         </p:nvSpPr>
@@ -7094,7 +7517,7 @@
       </p:sp>
       <p:sp>
         <p:nvSpPr>
-          <p:cNvPr id="20" name="TextBox 91"/>
+          <p:cNvPr id="20" name="TextBox 98"/>
           <p:cNvSpPr txBox="1"/>
           <p:nvPr/>
         </p:nvSpPr>
@@ -7151,7 +7574,7 @@
       </p:sp>
       <p:sp>
         <p:nvSpPr>
-          <p:cNvPr id="21" name="TextBox 92"/>
+          <p:cNvPr id="21" name="TextBox 99"/>
           <p:cNvSpPr txBox="1"/>
           <p:nvPr/>
         </p:nvSpPr>
@@ -7208,7 +7631,7 @@
       </p:sp>
       <p:sp>
         <p:nvSpPr>
-          <p:cNvPr id="22" name="TextBox 93"/>
+          <p:cNvPr id="22" name="TextBox 100"/>
           <p:cNvSpPr txBox="1"/>
           <p:nvPr/>
         </p:nvSpPr>
@@ -7332,7 +7755,7 @@
       </p:grpSpPr>
       <p:sp>
         <p:nvSpPr>
-          <p:cNvPr id="2" name="TextBox 95"/>
+          <p:cNvPr id="2" name="TextBox 102"/>
           <p:cNvSpPr txBox="1"/>
           <p:nvPr/>
         </p:nvSpPr>
@@ -7389,7 +7812,7 @@
       </p:sp>
       <p:sp>
         <p:nvSpPr>
-          <p:cNvPr id="3" name="TextBox 96"/>
+          <p:cNvPr id="3" name="TextBox 103"/>
           <p:cNvSpPr txBox="1"/>
           <p:nvPr/>
         </p:nvSpPr>
@@ -7508,7 +7931,7 @@
       </p:sp>
       <p:sp>
         <p:nvSpPr>
-          <p:cNvPr id="4" name="TextBox 97"/>
+          <p:cNvPr id="4" name="TextBox 104"/>
           <p:cNvSpPr txBox="1"/>
           <p:nvPr/>
         </p:nvSpPr>
@@ -7596,7 +8019,7 @@
       </p:sp>
       <p:sp>
         <p:nvSpPr>
-          <p:cNvPr id="5" name="TextBox 98"/>
+          <p:cNvPr id="5" name="TextBox 105"/>
           <p:cNvSpPr txBox="1"/>
           <p:nvPr/>
         </p:nvSpPr>
@@ -7684,7 +8107,7 @@
       </p:sp>
       <p:sp>
         <p:nvSpPr>
-          <p:cNvPr id="6" name="TextBox 99"/>
+          <p:cNvPr id="6" name="TextBox 106"/>
           <p:cNvSpPr txBox="1"/>
           <p:nvPr/>
         </p:nvSpPr>

</xml_diff>

<commit_message>
site: add the repository URL and GitHub action to the final slide
</commit_message>
<xml_diff>
--- a/slides/landing-tall.pptx
+++ b/slides/landing-tall.pptx
@@ -8025,6 +8025,63 @@
         </p:nvSpPr>
         <p:spPr>
           <a:xfrm>
+            <a:off x="406400" y="6273800"/>
+            <a:ext cx="4902200" cy="2870200"/>
+          </a:xfrm>
+          <a:prstGeom prst="rect">
+            <a:avLst/>
+          </a:prstGeom>
+          <a:noFill/>
+          <a:ln>
+            <a:noFill/>
+          </a:ln>
+        </p:spPr>
+        <p:txBody>
+          <a:bodyPr wrap="square" lIns="0" tIns="0" rIns="0" bIns="0" anchor="t" rtlCol="0">
+            <a:spAutoFit/>
+          </a:bodyPr>
+          <a:lstStyle/>
+          <a:p>
+            <a:pPr algn="l" marL="0" indent="0">
+              <a:lnSpc>
+                <a:spcPct val="100000"/>
+              </a:lnSpc>
+              <a:spcBef>
+                <a:spcPts val="0"/>
+              </a:spcBef>
+              <a:spcAft>
+                <a:spcPts val="0"/>
+              </a:spcAft>
+              <a:buNone/>
+            </a:pPr>
+            <a:r>
+              <a:rPr lang="en-US" sz="1800" b="1" i="0" u="none" strike="noStrike" dirty="0">
+                <a:solidFill>
+                  <a:srgbClr val="FFFFFF"/>
+                </a:solidFill>
+                <a:latin typeface="Calibri"/>
+                <a:cs typeface="Calibri"/>
+              </a:rPr>
+              <a:t>github.com/starling-build/starling</a:t>
+            </a:r>
+            <a:endParaRPr lang="en-US" sz="1800" b="1" i="0" u="none" strike="noStrike" dirty="0">
+              <a:solidFill>
+                <a:srgbClr val="FFFFFF"/>
+              </a:solidFill>
+              <a:latin typeface="Calibri"/>
+              <a:cs typeface="Calibri"/>
+            </a:endParaRPr>
+          </a:p>
+        </p:txBody>
+      </p:sp>
+      <p:sp>
+        <p:nvSpPr>
+          <p:cNvPr id="6" name="TextBox 106"/>
+          <p:cNvSpPr txBox="1"/>
+          <p:nvPr/>
+        </p:nvSpPr>
+        <p:spPr>
+          <a:xfrm>
             <a:off x="406400" y="6832600"/>
             <a:ext cx="4902200" cy="2311400"/>
           </a:xfrm>
@@ -8107,7 +8164,7 @@
       </p:sp>
       <p:sp>
         <p:nvSpPr>
-          <p:cNvPr id="6" name="TextBox 106"/>
+          <p:cNvPr id="7" name="TextBox 107"/>
           <p:cNvSpPr txBox="1"/>
           <p:nvPr/>
         </p:nvSpPr>

</xml_diff>